<commit_message>
slides(wmt14): simplify paper references
</commit_message>
<xml_diff>
--- a/slides/datasets-in-10-minutes-wmt14.pptx
+++ b/slides/datasets-in-10-minutes-wmt14.pptx
@@ -10382,7 +10382,7 @@
                           <a:ea typeface="Noto Sans CJK JP"/>
                           <a:cs typeface="Noto Sans"/>
                         </a:rPr>
-                        <a:t>PBMT（GNMT論文での比較値）</a:t>
+                        <a:t>PBMT</a:t>
                       </a:r>
                     </a:p>
                   </a:txBody>
@@ -10724,7 +10724,7 @@
                 <a:ea typeface="Noto Sans CJK JP"/>
                 <a:cs typeface="Noto Sans"/>
               </a:rPr>
-              <a:t>GNMT論文 Table 5。前処理や学習条件は各論文に従う。</a:t>
+              <a:t/>
             </a:r>
           </a:p>
         </p:txBody>

</xml_diff>

<commit_message>
Reflow wmt14 examples with complete originals first
</commit_message>
<xml_diff>
--- a/slides/datasets-in-10-minutes-wmt14.pptx
+++ b/slides/datasets-in-10-minutes-wmt14.pptx
@@ -39,7 +39,6 @@
     <p:sldId id="287" r:id="rId37"/>
     <p:sldId id="288" r:id="rId38"/>
     <p:sldId id="289" r:id="rId39"/>
-    <p:sldId id="290" r:id="rId40"/>
     <p:sldId id="291" r:id="rId41"/>
     <p:sldId id="292" r:id="rId42"/>
     <p:sldId id="293" r:id="rId43"/>
@@ -16278,28 +16277,20 @@
           </a:bodyPr>
           <a:lstStyle/>
           <a:p>
-            <a:pPr algn="l">
-              <a:lnSpc>
-                <a:spcPct val="110000"/>
-              </a:lnSpc>
-              <a:buNone/>
-              <a:defRPr sz="2800" b="0">
-                <a:solidFill>
-                  <a:srgbClr val="303437"/>
-                </a:solidFill>
-                <a:latin typeface="Noto Sans"/>
-              </a:defRPr>
-            </a:pPr>
-            <a:r>
-              <a:rPr sz="2800" b="1" lang="ja-JP" altLang="en-US">
-                <a:solidFill>
-                  <a:srgbClr val="303437"/>
-                </a:solidFill>
-                <a:latin typeface="Noto Sans"/>
-                <a:ea typeface="Noto Sans CJK JP"/>
-                <a:cs typeface="Noto Sans"/>
-              </a:rPr>
-              <a:t>追加例8：英語・ヒンディー語（1/2）</a:t>
+            <a:pPr>
+              <a:lnSpc>
+                <a:spcPts val="3247"/>
+              </a:lnSpc>
+            </a:pPr>
+            <a:r>
+              <a:rPr sz="2800" b="1">
+                <a:solidFill>
+                  <a:srgbClr val="303437"/>
+                </a:solidFill>
+                <a:latin typeface="Noto Sans"/>
+                <a:ea typeface="Noto Sans CJK JP"/>
+              </a:rPr>
+              <a:t>追加例8：英語・ヒンディー語</a:t>
             </a:r>
           </a:p>
         </p:txBody>
@@ -16354,14 +16345,14 @@
       </p:sp>
       <p:sp>
         <p:nvSpPr>
-          <p:cNvPr id="4" name="TextBox 3"/>
+          <p:cNvPr id="7" name="sources"/>
           <p:cNvSpPr txBox="1"/>
           <p:nvPr/>
         </p:nvSpPr>
         <p:spPr>
           <a:xfrm>
-            <a:off x="548640" y="1399032"/>
-            <a:ext cx="8046720" cy="201168"/>
+            <a:off x="502920" y="4700016"/>
+            <a:ext cx="8183879" cy="530352"/>
           </a:xfrm>
           <a:prstGeom prst="rect">
             <a:avLst/>
@@ -16376,24 +16367,24 @@
           <a:p>
             <a:pPr algn="l">
               <a:lnSpc>
-                <a:spcPct val="117000"/>
-              </a:lnSpc>
-              <a:spcBef>
-                <a:spcPts val="0"/>
-              </a:spcBef>
-              <a:spcAft>
-                <a:spcPts val="0"/>
-              </a:spcAft>
-              <a:buNone/>
-              <a:defRPr sz="1200" b="0">
-                <a:solidFill>
-                  <a:srgbClr val="303437"/>
-                </a:solidFill>
-                <a:latin typeface="Noto Sans"/>
-              </a:defRPr>
-            </a:pPr>
-            <a:r>
-              <a:rPr sz="1200" b="0" lang="ja-JP" altLang="en-US">
+                <a:spcPts val="940"/>
+              </a:lnSpc>
+              <a:spcBef>
+                <a:spcPts val="0"/>
+              </a:spcBef>
+              <a:spcAft>
+                <a:spcPts val="140"/>
+              </a:spcAft>
+              <a:buNone/>
+              <a:defRPr sz="810" b="0">
+                <a:solidFill>
+                  <a:srgbClr val="303437"/>
+                </a:solidFill>
+                <a:latin typeface="Noto Sans"/>
+              </a:defRPr>
+            </a:pPr>
+            <a:r>
+              <a:rPr sz="810" b="0" lang="ja-JP" altLang="en-US">
                 <a:solidFill>
                   <a:srgbClr val="626669"/>
                 </a:solidFill>
@@ -16401,21 +16392,140 @@
                 <a:ea typeface="Noto Sans CJK JP"/>
                 <a:cs typeface="Noto Sans"/>
               </a:rPr>
-              <a:t>英語／左：原文　右：日本語</a:t>
-            </a:r>
-          </a:p>
-        </p:txBody>
-      </p:sp>
-      <p:sp>
-        <p:nvSpPr>
-          <p:cNvPr id="5" name="quote-frame"/>
-          <p:cNvSpPr/>
+              <a:t>[1] wmt/wmt14、改訂b199e406。2026-10-18参照。 hi-en / test行17。</a:t>
+            </a:r>
+            <a:r>
+              <a:rPr sz="810" b="0" lang="ja-JP" altLang="en-US">
+                <a:solidFill>
+                  <a:srgbClr val="626669"/>
+                </a:solidFill>
+                <a:latin typeface="Noto Sans"/>
+                <a:ea typeface="Noto Sans CJK JP"/>
+                <a:cs typeface="Noto Sans"/>
+              </a:rPr>
+              <a:t>  </a:t>
+            </a:r>
+            <a:r>
+              <a:rPr sz="810" b="0" lang="ja-JP" altLang="en-US">
+                <a:solidFill>
+                  <a:srgbClr val="626669"/>
+                </a:solidFill>
+                <a:latin typeface="Noto Sans"/>
+                <a:ea typeface="Noto Sans CJK JP"/>
+                <a:cs typeface="Noto Sans"/>
+                <a:hlinkClick r:id="rId2"/>
+              </a:rPr>
+              <a:t>https://huggingface.co/datasets/wmt/wmt14</a:t>
+            </a:r>
+          </a:p>
+        </p:txBody>
+      </p:sp>
+      <p:sp>
+        <p:nvSpPr>
+          <p:cNvPr id="8" name="original-label"/>
+          <p:cNvSpPr txBox="1"/>
           <p:nvPr/>
         </p:nvSpPr>
         <p:spPr>
           <a:xfrm>
+            <a:off x="548640" y="1399032"/>
+            <a:ext cx="3858768" cy="201168"/>
+          </a:xfrm>
+          <a:prstGeom prst="rect">
+            <a:avLst/>
+          </a:prstGeom>
+          <a:noFill/>
+        </p:spPr>
+        <p:txBody>
+          <a:bodyPr wrap="square" lIns="0" rIns="0" tIns="0" bIns="0">
+            <a:noAutofit/>
+          </a:bodyPr>
+          <a:lstStyle/>
+          <a:p>
+            <a:pPr>
+              <a:lnSpc>
+                <a:spcPts val="1464"/>
+              </a:lnSpc>
+              <a:spcBef>
+                <a:spcPts val="0"/>
+              </a:spcBef>
+              <a:spcAft>
+                <a:spcPts val="0"/>
+              </a:spcAft>
+              <a:buNone/>
+            </a:pPr>
+            <a:r>
+              <a:rPr sz="1200" b="0" lang="ja-JP">
+                <a:solidFill>
+                  <a:srgbClr val="626669"/>
+                </a:solidFill>
+                <a:latin typeface="Noto Sans"/>
+                <a:ea typeface="Noto Sans CJK JP"/>
+                <a:cs typeface="Noto Sans"/>
+              </a:rPr>
+              <a:t>原文</a:t>
+            </a:r>
+          </a:p>
+        </p:txBody>
+      </p:sp>
+      <p:sp>
+        <p:nvSpPr>
+          <p:cNvPr id="9" name="translation-label"/>
+          <p:cNvSpPr txBox="1"/>
+          <p:nvPr/>
+        </p:nvSpPr>
+        <p:spPr>
+          <a:xfrm>
+            <a:off x="4681727" y="1399032"/>
+            <a:ext cx="3913632" cy="201168"/>
+          </a:xfrm>
+          <a:prstGeom prst="rect">
+            <a:avLst/>
+          </a:prstGeom>
+          <a:noFill/>
+        </p:spPr>
+        <p:txBody>
+          <a:bodyPr wrap="square" lIns="0" rIns="0" tIns="0" bIns="0">
+            <a:noAutofit/>
+          </a:bodyPr>
+          <a:lstStyle/>
+          <a:p>
+            <a:pPr>
+              <a:lnSpc>
+                <a:spcPts val="1464"/>
+              </a:lnSpc>
+              <a:spcBef>
+                <a:spcPts val="0"/>
+              </a:spcBef>
+              <a:spcAft>
+                <a:spcPts val="0"/>
+              </a:spcAft>
+              <a:buNone/>
+            </a:pPr>
+            <a:r>
+              <a:rPr sz="1200" b="0" lang="ja-JP">
+                <a:solidFill>
+                  <a:srgbClr val="626669"/>
+                </a:solidFill>
+                <a:latin typeface="Noto Sans"/>
+                <a:ea typeface="Noto Sans CJK JP"/>
+                <a:cs typeface="Noto Sans"/>
+              </a:rPr>
+              <a:t>日本語訳</a:t>
+            </a:r>
+          </a:p>
+        </p:txBody>
+      </p:sp>
+      <p:sp>
+        <p:nvSpPr>
+          <p:cNvPr id="10" name="original-panel"/>
+          <p:cNvSpPr txBox="1"/>
+          <p:nvPr/>
+        </p:nvSpPr>
+        <p:spPr>
+          <a:xfrm>
             <a:off x="548640" y="1655064"/>
-            <a:ext cx="3858768" cy="1092771"/>
+            <a:ext cx="3858768" cy="2260473"/>
           </a:xfrm>
           <a:prstGeom prst="rect">
             <a:avLst/>
@@ -16426,70 +16536,74 @@
           <a:ln>
             <a:noFill/>
           </a:ln>
-          <a:effectLst/>
-        </p:spPr>
-        <p:style>
-          <a:lnRef idx="1">
-            <a:schemeClr val="accent1"/>
-          </a:lnRef>
-          <a:fillRef idx="3">
-            <a:schemeClr val="accent1"/>
-          </a:fillRef>
-          <a:effectRef idx="0">
-            <a:schemeClr val="accent1"/>
-          </a:effectRef>
-          <a:fontRef idx="minor">
-            <a:schemeClr val="lt1"/>
-          </a:fontRef>
-        </p:style>
-        <p:txBody>
-          <a:bodyPr rtlCol="0" anchor="ctr" wrap="square" lIns="177800" rIns="177800" tIns="101600" bIns="127000">
+        </p:spPr>
+        <p:txBody>
+          <a:bodyPr wrap="square" lIns="152400" rIns="152400" tIns="101600" bIns="101600">
             <a:noAutofit/>
           </a:bodyPr>
           <a:lstStyle/>
           <a:p>
-            <a:pPr algn="l">
-              <a:lnSpc>
-                <a:spcPts val="2201"/>
-              </a:lnSpc>
-              <a:spcBef>
-                <a:spcPts val="0"/>
-              </a:spcBef>
-              <a:spcAft>
-                <a:spcPts val="0"/>
-              </a:spcAft>
-              <a:buNone/>
-              <a:defRPr sz="1850" b="0">
-                <a:solidFill>
-                  <a:srgbClr val="303437"/>
-                </a:solidFill>
-                <a:latin typeface="Noto Sans"/>
-              </a:defRPr>
-            </a:pPr>
-            <a:r>
-              <a:rPr sz="1850" b="0" lang="ja-JP" altLang="en-US">
-                <a:solidFill>
-                  <a:srgbClr val="303437"/>
-                </a:solidFill>
-                <a:latin typeface="Noto Sans"/>
-                <a:ea typeface="Noto Sans CJK JP"/>
-                <a:cs typeface="Noto Sans"/>
-              </a:rPr>
-              <a:t>The federal tax itself, 18.4 cents per gallon, hasn't gone up in 20 years.</a:t>
-            </a:r>
-          </a:p>
-        </p:txBody>
-      </p:sp>
-      <p:sp>
-        <p:nvSpPr>
-          <p:cNvPr id="6" name="TextBox 5"/>
+            <a:pPr>
+              <a:lnSpc>
+                <a:spcPts val="2257"/>
+              </a:lnSpc>
+              <a:spcBef>
+                <a:spcPts val="0"/>
+              </a:spcBef>
+              <a:spcAft>
+                <a:spcPts val="0"/>
+              </a:spcAft>
+              <a:buNone/>
+            </a:pPr>
+            <a:r>
+              <a:rPr sz="1850" b="0" lang="ja-JP">
+                <a:solidFill>
+                  <a:srgbClr val="303437"/>
+                </a:solidFill>
+                <a:latin typeface="Noto Sans"/>
+                <a:ea typeface="Noto Sans CJK JP"/>
+                <a:cs typeface="Noto Sans"/>
+              </a:rPr>
+              <a:t>English: The federal tax itself, 18.4 cents per gallon, hasn't gone up in 20 years.</a:t>
+            </a:r>
+          </a:p>
+          <a:p>
+            <a:pPr>
+              <a:lnSpc>
+                <a:spcPts val="2257"/>
+              </a:lnSpc>
+              <a:spcBef>
+                <a:spcPts val="0"/>
+              </a:spcBef>
+              <a:spcAft>
+                <a:spcPts val="0"/>
+              </a:spcAft>
+              <a:buNone/>
+            </a:pPr>
+            <a:r>
+              <a:rPr sz="1850" b="0" lang="ja-JP">
+                <a:solidFill>
+                  <a:srgbClr val="303437"/>
+                </a:solidFill>
+                <a:latin typeface="Noto Sans"/>
+                <a:ea typeface="Noto Sans CJK JP"/>
+                <a:cs typeface="Noto Sans"/>
+              </a:rPr>
+              <a:t>Hindi: फेडरल टैक्स में पिछले 20 वर्षों में कोई बढ़ोतरी नहीं हुई, जो 18.4 सेंट प्रति गैलन है।</a:t>
+            </a:r>
+          </a:p>
+        </p:txBody>
+      </p:sp>
+      <p:sp>
+        <p:nvSpPr>
+          <p:cNvPr id="11" name="translation-body"/>
           <p:cNvSpPr txBox="1"/>
           <p:nvPr/>
         </p:nvSpPr>
         <p:spPr>
           <a:xfrm>
-            <a:off x="4690872" y="1673352"/>
-            <a:ext cx="3858768" cy="893635"/>
+            <a:off x="4681727" y="1664208"/>
+            <a:ext cx="3913632" cy="1703069"/>
           </a:xfrm>
           <a:prstGeom prst="rect">
             <a:avLst/>
@@ -16497,117 +16611,108 @@
           <a:noFill/>
         </p:spPr>
         <p:txBody>
-          <a:bodyPr wrap="square" lIns="0" rIns="0" tIns="0" bIns="0" anchor="t">
-            <a:noAutofit/>
-          </a:bodyPr>
-          <a:lstStyle/>
-          <a:p>
-            <a:pPr algn="l">
-              <a:lnSpc>
-                <a:spcPts val="2201"/>
-              </a:lnSpc>
-              <a:spcBef>
-                <a:spcPts val="0"/>
-              </a:spcBef>
-              <a:spcAft>
-                <a:spcPts val="0"/>
-              </a:spcAft>
-              <a:buNone/>
-              <a:defRPr sz="1850" b="0">
-                <a:solidFill>
-                  <a:srgbClr val="303437"/>
-                </a:solidFill>
-                <a:latin typeface="Noto Sans"/>
-              </a:defRPr>
-            </a:pPr>
-            <a:r>
-              <a:rPr sz="1850" b="0" lang="ja-JP" altLang="en-US">
-                <a:solidFill>
-                  <a:srgbClr val="303437"/>
-                </a:solidFill>
-                <a:latin typeface="Noto Sans"/>
-                <a:ea typeface="Noto Sans CJK JP"/>
-                <a:cs typeface="Noto Sans"/>
-              </a:rPr>
-              <a:t>連邦税自体は1ガロン当たり18.4セント。
-20年間据え置かれている。</a:t>
-            </a:r>
-          </a:p>
-        </p:txBody>
-      </p:sp>
-      <p:sp>
-        <p:nvSpPr>
-          <p:cNvPr id="7" name="sources"/>
-          <p:cNvSpPr txBox="1"/>
-          <p:nvPr/>
-        </p:nvSpPr>
-        <p:spPr>
-          <a:xfrm>
-            <a:off x="502920" y="4700016"/>
-            <a:ext cx="8183879" cy="530352"/>
-          </a:xfrm>
-          <a:prstGeom prst="rect">
-            <a:avLst/>
-          </a:prstGeom>
-          <a:noFill/>
-        </p:spPr>
-        <p:txBody>
           <a:bodyPr wrap="square" lIns="0" rIns="0" tIns="0" bIns="0">
             <a:noAutofit/>
           </a:bodyPr>
           <a:lstStyle/>
           <a:p>
-            <a:pPr algn="l">
-              <a:lnSpc>
-                <a:spcPts val="940"/>
-              </a:lnSpc>
-              <a:spcBef>
-                <a:spcPts val="0"/>
-              </a:spcBef>
-              <a:spcAft>
-                <a:spcPts val="140"/>
-              </a:spcAft>
-              <a:buNone/>
-              <a:defRPr sz="810" b="0">
-                <a:solidFill>
-                  <a:srgbClr val="303437"/>
-                </a:solidFill>
-                <a:latin typeface="Noto Sans"/>
-              </a:defRPr>
-            </a:pPr>
-            <a:r>
-              <a:rPr sz="810" b="0" lang="ja-JP" altLang="en-US">
-                <a:solidFill>
-                  <a:srgbClr val="626669"/>
-                </a:solidFill>
-                <a:latin typeface="Noto Sans"/>
-                <a:ea typeface="Noto Sans CJK JP"/>
-                <a:cs typeface="Noto Sans"/>
-              </a:rPr>
-              <a:t>[1] wmt/wmt14、改訂b199e406。2026-10-18参照。 hi-en / test行17。</a:t>
-            </a:r>
-            <a:r>
-              <a:rPr sz="810" b="0" lang="ja-JP" altLang="en-US">
-                <a:solidFill>
-                  <a:srgbClr val="626669"/>
-                </a:solidFill>
-                <a:latin typeface="Noto Sans"/>
-                <a:ea typeface="Noto Sans CJK JP"/>
-                <a:cs typeface="Noto Sans"/>
-              </a:rPr>
-              <a:t>  </a:t>
-            </a:r>
-            <a:r>
-              <a:rPr sz="810" b="0" lang="ja-JP" altLang="en-US">
-                <a:solidFill>
-                  <a:srgbClr val="626669"/>
-                </a:solidFill>
-                <a:latin typeface="Noto Sans"/>
-                <a:ea typeface="Noto Sans CJK JP"/>
-                <a:cs typeface="Noto Sans"/>
-                <a:hlinkClick r:id="rId2"/>
-              </a:rPr>
-              <a:t>https://huggingface.co/datasets/wmt/wmt14</a:t>
+            <a:pPr>
+              <a:lnSpc>
+                <a:spcPts val="2135"/>
+              </a:lnSpc>
+              <a:spcBef>
+                <a:spcPts val="0"/>
+              </a:spcBef>
+              <a:spcAft>
+                <a:spcPts val="0"/>
+              </a:spcAft>
+              <a:buNone/>
+            </a:pPr>
+            <a:r>
+              <a:rPr sz="1750" b="0" lang="ja-JP">
+                <a:solidFill>
+                  <a:srgbClr val="303437"/>
+                </a:solidFill>
+                <a:latin typeface="Noto Sans"/>
+                <a:ea typeface="Noto Sans CJK JP"/>
+                <a:cs typeface="Noto Sans"/>
+              </a:rPr>
+              <a:t>英語：連邦税自体は1ガロン当たり18.4セント。</a:t>
+            </a:r>
+          </a:p>
+          <a:p>
+            <a:pPr>
+              <a:lnSpc>
+                <a:spcPts val="2135"/>
+              </a:lnSpc>
+              <a:spcBef>
+                <a:spcPts val="0"/>
+              </a:spcBef>
+              <a:spcAft>
+                <a:spcPts val="0"/>
+              </a:spcAft>
+              <a:buNone/>
+            </a:pPr>
+            <a:r>
+              <a:rPr sz="1750" b="0" lang="ja-JP">
+                <a:solidFill>
+                  <a:srgbClr val="303437"/>
+                </a:solidFill>
+                <a:latin typeface="Noto Sans"/>
+                <a:ea typeface="Noto Sans CJK JP"/>
+                <a:cs typeface="Noto Sans"/>
+              </a:rPr>
+              <a:t>20年間据え置かれている。</a:t>
+            </a:r>
+          </a:p>
+          <a:p>
+            <a:pPr>
+              <a:lnSpc>
+                <a:spcPts val="2135"/>
+              </a:lnSpc>
+              <a:spcBef>
+                <a:spcPts val="0"/>
+              </a:spcBef>
+              <a:spcAft>
+                <a:spcPts val="0"/>
+              </a:spcAft>
+              <a:buNone/>
+            </a:pPr>
+            <a:r>
+              <a:rPr sz="1750" b="0" lang="ja-JP">
+                <a:solidFill>
+                  <a:srgbClr val="303437"/>
+                </a:solidFill>
+                <a:latin typeface="Noto Sans"/>
+                <a:ea typeface="Noto Sans CJK JP"/>
+                <a:cs typeface="Noto Sans"/>
+              </a:rPr>
+              <a:t>ヒンディー語の参照訳：連邦税自体は1ガロン当たり18.4セント。</a:t>
+            </a:r>
+          </a:p>
+          <a:p>
+            <a:pPr>
+              <a:lnSpc>
+                <a:spcPts val="2135"/>
+              </a:lnSpc>
+              <a:spcBef>
+                <a:spcPts val="0"/>
+              </a:spcBef>
+              <a:spcAft>
+                <a:spcPts val="0"/>
+              </a:spcAft>
+              <a:buNone/>
+            </a:pPr>
+            <a:r>
+              <a:rPr sz="1750" b="0" lang="ja-JP">
+                <a:solidFill>
+                  <a:srgbClr val="303437"/>
+                </a:solidFill>
+                <a:latin typeface="Noto Sans"/>
+                <a:ea typeface="Noto Sans CJK JP"/>
+                <a:cs typeface="Noto Sans"/>
+              </a:rPr>
+              <a:t>20年間据え置かれている。</a:t>
             </a:r>
           </a:p>
         </p:txBody>
@@ -16673,7 +16778,7 @@
                 <a:ea typeface="Noto Sans CJK JP"/>
                 <a:cs typeface="Noto Sans"/>
               </a:rPr>
-              <a:t>追加例8：英語・ヒンディー語（2/2）</a:t>
+              <a:t>追加例9：英語・ロシア語</a:t>
             </a:r>
           </a:p>
         </p:txBody>
@@ -16775,7 +16880,7 @@
                 <a:ea typeface="Noto Sans CJK JP"/>
                 <a:cs typeface="Noto Sans"/>
               </a:rPr>
-              <a:t>ヒンディー語の参照訳／原文と日本語</a:t>
+              <a:t>関連する入力・回答／原文と日本語</a:t>
             </a:r>
           </a:p>
         </p:txBody>
@@ -16849,7 +16954,38 @@
                 <a:ea typeface="Noto Sans CJK JP"/>
                 <a:cs typeface="Noto Sans"/>
               </a:rPr>
-              <a:t>फेडरल टैक्स में पिछले 20 वर्षों में कोई बढ़ोतरी नहीं हुई, जो 18.4 सेंट प्रति गैलन है।</a:t>
+              <a:t>In Kineshma and environs two men have committed suicide</a:t>
+            </a:r>
+          </a:p>
+          <a:p>
+            <a:pPr algn="l">
+              <a:lnSpc>
+                <a:spcPts val="2201"/>
+              </a:lnSpc>
+              <a:spcBef>
+                <a:spcPts val="0"/>
+              </a:spcBef>
+              <a:spcAft>
+                <a:spcPts val="0"/>
+              </a:spcAft>
+              <a:buNone/>
+              <a:defRPr sz="1850" b="0">
+                <a:solidFill>
+                  <a:srgbClr val="303437"/>
+                </a:solidFill>
+                <a:latin typeface="Noto Sans"/>
+              </a:defRPr>
+            </a:pPr>
+            <a:r>
+              <a:rPr sz="1850" b="0" lang="ja-JP" altLang="en-US">
+                <a:solidFill>
+                  <a:srgbClr val="303437"/>
+                </a:solidFill>
+                <a:latin typeface="Noto Sans"/>
+                <a:ea typeface="Noto Sans CJK JP"/>
+                <a:cs typeface="Noto Sans"/>
+              </a:rPr>
+              <a:t>В Кинешме и районе двое мужчин покончили жизнь самоубийством</a:t>
             </a:r>
           </a:p>
         </p:txBody>
@@ -16903,8 +17039,38 @@
                 <a:ea typeface="Noto Sans CJK JP"/>
                 <a:cs typeface="Noto Sans"/>
               </a:rPr>
-              <a:t>連邦税自体は1ガロン当たり18.4セント。
-20年間据え置かれている。</a:t>
+              <a:t>英語：キネシマとその周辺で、男性2人が自殺した。</a:t>
+            </a:r>
+          </a:p>
+          <a:p>
+            <a:pPr algn="l">
+              <a:lnSpc>
+                <a:spcPts val="2201"/>
+              </a:lnSpc>
+              <a:spcBef>
+                <a:spcPts val="0"/>
+              </a:spcBef>
+              <a:spcAft>
+                <a:spcPts val="0"/>
+              </a:spcAft>
+              <a:buNone/>
+              <a:defRPr sz="1850" b="0">
+                <a:solidFill>
+                  <a:srgbClr val="303437"/>
+                </a:solidFill>
+                <a:latin typeface="Noto Sans"/>
+              </a:defRPr>
+            </a:pPr>
+            <a:r>
+              <a:rPr sz="1850" b="0" lang="ja-JP" altLang="en-US">
+                <a:solidFill>
+                  <a:srgbClr val="303437"/>
+                </a:solidFill>
+                <a:latin typeface="Noto Sans"/>
+                <a:ea typeface="Noto Sans CJK JP"/>
+                <a:cs typeface="Noto Sans"/>
+              </a:rPr>
+              <a:t>ロシア語の参照訳：キネシマとその周辺で、男性2人が自殺した。</a:t>
             </a:r>
           </a:p>
         </p:txBody>
@@ -16958,7 +17124,7 @@
                 <a:ea typeface="Noto Sans CJK JP"/>
                 <a:cs typeface="Noto Sans"/>
               </a:rPr>
-              <a:t>[1] wmt/wmt14、改訂b199e406。2026-10-18参照。 hi-en / test行17。</a:t>
+              <a:t>[1] wmt/wmt14、改訂b199e406。2026-10-18参照。 ru-en / test行0。</a:t>
             </a:r>
             <a:r>
               <a:rPr sz="810" b="0" lang="ja-JP" altLang="en-US">
@@ -17047,7 +17213,7 @@
                 <a:ea typeface="Noto Sans CJK JP"/>
                 <a:cs typeface="Noto Sans"/>
               </a:rPr>
-              <a:t>追加例9：英語・ロシア語</a:t>
+              <a:t>追加例10：英語・ロシア語</a:t>
             </a:r>
           </a:p>
         </p:txBody>
@@ -17163,7 +17329,7 @@
         <p:spPr>
           <a:xfrm>
             <a:off x="548640" y="1655064"/>
-            <a:ext cx="8046720" cy="1092771"/>
+            <a:ext cx="8046720" cy="813181"/>
           </a:xfrm>
           <a:prstGeom prst="rect">
             <a:avLst/>
@@ -17223,7 +17389,7 @@
                 <a:ea typeface="Noto Sans CJK JP"/>
                 <a:cs typeface="Noto Sans"/>
               </a:rPr>
-              <a:t>In Kineshma and environs two men have committed suicide</a:t>
+              <a:t>One of the hanged men had previously attempted suicide.</a:t>
             </a:r>
           </a:p>
           <a:p>
@@ -17254,7 +17420,7 @@
                 <a:ea typeface="Noto Sans CJK JP"/>
                 <a:cs typeface="Noto Sans"/>
               </a:rPr>
-              <a:t>В Кинешме и районе двое мужчин покончили жизнь самоубийством</a:t>
+              <a:t>Ранее один из повешенных уже совершал попытку суицида.</a:t>
             </a:r>
           </a:p>
         </p:txBody>
@@ -17267,8 +17433,8 @@
         </p:nvSpPr>
         <p:spPr>
           <a:xfrm>
-            <a:off x="594360" y="2802699"/>
-            <a:ext cx="7955279" cy="614045"/>
+            <a:off x="594360" y="2523109"/>
+            <a:ext cx="7955279" cy="893635"/>
           </a:xfrm>
           <a:prstGeom prst="rect">
             <a:avLst/>
@@ -17308,7 +17474,7 @@
                 <a:ea typeface="Noto Sans CJK JP"/>
                 <a:cs typeface="Noto Sans"/>
               </a:rPr>
-              <a:t>英語：キネシマとその周辺で、男性2人が自殺した。</a:t>
+              <a:t>英語：首をつって亡くなった男性の1人には、過去に自殺未遂があった。</a:t>
             </a:r>
           </a:p>
           <a:p>
@@ -17339,7 +17505,7 @@
                 <a:ea typeface="Noto Sans CJK JP"/>
                 <a:cs typeface="Noto Sans"/>
               </a:rPr>
-              <a:t>ロシア語の参照訳：キネシマとその周辺で、男性2人が自殺した。</a:t>
+              <a:t>ロシア語の参照訳：首をつって亡くなった男性の1人には、過去に自殺未遂があった。</a:t>
             </a:r>
           </a:p>
         </p:txBody>
@@ -17393,7 +17559,7 @@
                 <a:ea typeface="Noto Sans CJK JP"/>
                 <a:cs typeface="Noto Sans"/>
               </a:rPr>
-              <a:t>[1] wmt/wmt14、改訂b199e406。2026-10-18参照。 ru-en / test行0。</a:t>
+              <a:t>[1] wmt/wmt14、改訂b199e406。2026-10-18参照。 ru-en / test行1。</a:t>
             </a:r>
             <a:r>
               <a:rPr sz="810" b="0" lang="ja-JP" altLang="en-US">
@@ -17451,38 +17617,38 @@
         </p:nvSpPr>
         <p:spPr>
           <a:xfrm>
-            <a:off x="468172" y="650138"/>
-            <a:ext cx="8206740" cy="616305"/>
-          </a:xfrm>
-        </p:spPr>
-        <p:txBody>
-          <a:bodyPr wrap="square" lIns="0" rIns="0" tIns="0" bIns="0">
+            <a:off x="548640" y="2506875"/>
+            <a:ext cx="8046720" cy="585216"/>
+          </a:xfrm>
+        </p:spPr>
+        <p:txBody>
+          <a:bodyPr wrap="square" lIns="0" rIns="0" tIns="0" bIns="0" anchor="ctr">
             <a:noAutofit/>
           </a:bodyPr>
           <a:lstStyle/>
           <a:p>
-            <a:pPr algn="l">
+            <a:pPr algn="ctr">
               <a:lnSpc>
                 <a:spcPct val="110000"/>
               </a:lnSpc>
               <a:buNone/>
-              <a:defRPr sz="2800" b="0">
-                <a:solidFill>
-                  <a:srgbClr val="303437"/>
-                </a:solidFill>
-                <a:latin typeface="Noto Sans"/>
-              </a:defRPr>
-            </a:pPr>
-            <a:r>
-              <a:rPr sz="2800" b="1" lang="ja-JP" altLang="en-US">
-                <a:solidFill>
-                  <a:srgbClr val="303437"/>
-                </a:solidFill>
-                <a:latin typeface="Noto Sans"/>
-                <a:ea typeface="Noto Sans CJK JP"/>
-                <a:cs typeface="Noto Sans"/>
-              </a:rPr>
-              <a:t>追加例10：英語・ロシア語</a:t>
+              <a:defRPr sz="3600" b="0">
+                <a:solidFill>
+                  <a:srgbClr val="303437"/>
+                </a:solidFill>
+                <a:latin typeface="Noto Sans"/>
+              </a:defRPr>
+            </a:pPr>
+            <a:r>
+              <a:rPr sz="3600" b="1" lang="ja-JP" altLang="en-US">
+                <a:solidFill>
+                  <a:srgbClr val="303437"/>
+                </a:solidFill>
+                <a:latin typeface="Noto Sans"/>
+                <a:ea typeface="Noto Sans CJK JP"/>
+                <a:cs typeface="Noto Sans"/>
+              </a:rPr>
+              <a:t>集計と評価条件</a:t>
             </a:r>
           </a:p>
         </p:txBody>
@@ -17530,328 +17696,7 @@
                 <a:ea typeface="Noto Sans CJK JP"/>
                 <a:cs typeface="Noto Sans"/>
               </a:rPr>
-              <a:t>Appendix: 1. 題材の異なる追加例</a:t>
-            </a:r>
-          </a:p>
-        </p:txBody>
-      </p:sp>
-      <p:sp>
-        <p:nvSpPr>
-          <p:cNvPr id="4" name="TextBox 3"/>
-          <p:cNvSpPr txBox="1"/>
-          <p:nvPr/>
-        </p:nvSpPr>
-        <p:spPr>
-          <a:xfrm>
-            <a:off x="548640" y="1399032"/>
-            <a:ext cx="8046720" cy="201168"/>
-          </a:xfrm>
-          <a:prstGeom prst="rect">
-            <a:avLst/>
-          </a:prstGeom>
-          <a:noFill/>
-        </p:spPr>
-        <p:txBody>
-          <a:bodyPr wrap="square" lIns="0" rIns="0" tIns="0" bIns="0">
-            <a:noAutofit/>
-          </a:bodyPr>
-          <a:lstStyle/>
-          <a:p>
-            <a:pPr algn="l">
-              <a:lnSpc>
-                <a:spcPct val="117000"/>
-              </a:lnSpc>
-              <a:spcBef>
-                <a:spcPts val="0"/>
-              </a:spcBef>
-              <a:spcAft>
-                <a:spcPts val="0"/>
-              </a:spcAft>
-              <a:buNone/>
-              <a:defRPr sz="1200" b="0">
-                <a:solidFill>
-                  <a:srgbClr val="303437"/>
-                </a:solidFill>
-                <a:latin typeface="Noto Sans"/>
-              </a:defRPr>
-            </a:pPr>
-            <a:r>
-              <a:rPr sz="1200" b="0" lang="ja-JP" altLang="en-US">
-                <a:solidFill>
-                  <a:srgbClr val="626669"/>
-                </a:solidFill>
-                <a:latin typeface="Noto Sans"/>
-                <a:ea typeface="Noto Sans CJK JP"/>
-                <a:cs typeface="Noto Sans"/>
-              </a:rPr>
-              <a:t>関連する入力・回答／原文と日本語</a:t>
-            </a:r>
-          </a:p>
-        </p:txBody>
-      </p:sp>
-      <p:sp>
-        <p:nvSpPr>
-          <p:cNvPr id="5" name="quote-frame"/>
-          <p:cNvSpPr/>
-          <p:nvPr/>
-        </p:nvSpPr>
-        <p:spPr>
-          <a:xfrm>
-            <a:off x="548640" y="1655064"/>
-            <a:ext cx="8046720" cy="813181"/>
-          </a:xfrm>
-          <a:prstGeom prst="rect">
-            <a:avLst/>
-          </a:prstGeom>
-          <a:solidFill>
-            <a:srgbClr val="EBEDEB"/>
-          </a:solidFill>
-          <a:ln>
-            <a:noFill/>
-          </a:ln>
-          <a:effectLst/>
-        </p:spPr>
-        <p:style>
-          <a:lnRef idx="1">
-            <a:schemeClr val="accent1"/>
-          </a:lnRef>
-          <a:fillRef idx="3">
-            <a:schemeClr val="accent1"/>
-          </a:fillRef>
-          <a:effectRef idx="0">
-            <a:schemeClr val="accent1"/>
-          </a:effectRef>
-          <a:fontRef idx="minor">
-            <a:schemeClr val="lt1"/>
-          </a:fontRef>
-        </p:style>
-        <p:txBody>
-          <a:bodyPr rtlCol="0" anchor="ctr" wrap="square" lIns="177800" rIns="177800" tIns="101600" bIns="127000">
-            <a:noAutofit/>
-          </a:bodyPr>
-          <a:lstStyle/>
-          <a:p>
-            <a:pPr algn="l">
-              <a:lnSpc>
-                <a:spcPts val="2201"/>
-              </a:lnSpc>
-              <a:spcBef>
-                <a:spcPts val="0"/>
-              </a:spcBef>
-              <a:spcAft>
-                <a:spcPts val="0"/>
-              </a:spcAft>
-              <a:buNone/>
-              <a:defRPr sz="1850" b="0">
-                <a:solidFill>
-                  <a:srgbClr val="303437"/>
-                </a:solidFill>
-                <a:latin typeface="Noto Sans"/>
-              </a:defRPr>
-            </a:pPr>
-            <a:r>
-              <a:rPr sz="1850" b="0" lang="ja-JP" altLang="en-US">
-                <a:solidFill>
-                  <a:srgbClr val="303437"/>
-                </a:solidFill>
-                <a:latin typeface="Noto Sans"/>
-                <a:ea typeface="Noto Sans CJK JP"/>
-                <a:cs typeface="Noto Sans"/>
-              </a:rPr>
-              <a:t>One of the hanged men had previously attempted suicide.</a:t>
-            </a:r>
-          </a:p>
-          <a:p>
-            <a:pPr algn="l">
-              <a:lnSpc>
-                <a:spcPts val="2201"/>
-              </a:lnSpc>
-              <a:spcBef>
-                <a:spcPts val="0"/>
-              </a:spcBef>
-              <a:spcAft>
-                <a:spcPts val="0"/>
-              </a:spcAft>
-              <a:buNone/>
-              <a:defRPr sz="1850" b="0">
-                <a:solidFill>
-                  <a:srgbClr val="303437"/>
-                </a:solidFill>
-                <a:latin typeface="Noto Sans"/>
-              </a:defRPr>
-            </a:pPr>
-            <a:r>
-              <a:rPr sz="1850" b="0" lang="ja-JP" altLang="en-US">
-                <a:solidFill>
-                  <a:srgbClr val="303437"/>
-                </a:solidFill>
-                <a:latin typeface="Noto Sans"/>
-                <a:ea typeface="Noto Sans CJK JP"/>
-                <a:cs typeface="Noto Sans"/>
-              </a:rPr>
-              <a:t>Ранее один из повешенных уже совершал попытку суицида.</a:t>
-            </a:r>
-          </a:p>
-        </p:txBody>
-      </p:sp>
-      <p:sp>
-        <p:nvSpPr>
-          <p:cNvPr id="6" name="TextBox 5"/>
-          <p:cNvSpPr txBox="1"/>
-          <p:nvPr/>
-        </p:nvSpPr>
-        <p:spPr>
-          <a:xfrm>
-            <a:off x="594360" y="2523109"/>
-            <a:ext cx="7955279" cy="893635"/>
-          </a:xfrm>
-          <a:prstGeom prst="rect">
-            <a:avLst/>
-          </a:prstGeom>
-          <a:noFill/>
-        </p:spPr>
-        <p:txBody>
-          <a:bodyPr wrap="square" lIns="0" rIns="0" tIns="0" bIns="0" anchor="t">
-            <a:noAutofit/>
-          </a:bodyPr>
-          <a:lstStyle/>
-          <a:p>
-            <a:pPr algn="l">
-              <a:lnSpc>
-                <a:spcPts val="2201"/>
-              </a:lnSpc>
-              <a:spcBef>
-                <a:spcPts val="0"/>
-              </a:spcBef>
-              <a:spcAft>
-                <a:spcPts val="0"/>
-              </a:spcAft>
-              <a:buNone/>
-              <a:defRPr sz="1850" b="0">
-                <a:solidFill>
-                  <a:srgbClr val="303437"/>
-                </a:solidFill>
-                <a:latin typeface="Noto Sans"/>
-              </a:defRPr>
-            </a:pPr>
-            <a:r>
-              <a:rPr sz="1850" b="0" lang="ja-JP" altLang="en-US">
-                <a:solidFill>
-                  <a:srgbClr val="303437"/>
-                </a:solidFill>
-                <a:latin typeface="Noto Sans"/>
-                <a:ea typeface="Noto Sans CJK JP"/>
-                <a:cs typeface="Noto Sans"/>
-              </a:rPr>
-              <a:t>英語：首をつって亡くなった男性の1人には、過去に自殺未遂があった。</a:t>
-            </a:r>
-          </a:p>
-          <a:p>
-            <a:pPr algn="l">
-              <a:lnSpc>
-                <a:spcPts val="2201"/>
-              </a:lnSpc>
-              <a:spcBef>
-                <a:spcPts val="0"/>
-              </a:spcBef>
-              <a:spcAft>
-                <a:spcPts val="0"/>
-              </a:spcAft>
-              <a:buNone/>
-              <a:defRPr sz="1850" b="0">
-                <a:solidFill>
-                  <a:srgbClr val="303437"/>
-                </a:solidFill>
-                <a:latin typeface="Noto Sans"/>
-              </a:defRPr>
-            </a:pPr>
-            <a:r>
-              <a:rPr sz="1850" b="0" lang="ja-JP" altLang="en-US">
-                <a:solidFill>
-                  <a:srgbClr val="303437"/>
-                </a:solidFill>
-                <a:latin typeface="Noto Sans"/>
-                <a:ea typeface="Noto Sans CJK JP"/>
-                <a:cs typeface="Noto Sans"/>
-              </a:rPr>
-              <a:t>ロシア語の参照訳：首をつって亡くなった男性の1人には、過去に自殺未遂があった。</a:t>
-            </a:r>
-          </a:p>
-        </p:txBody>
-      </p:sp>
-      <p:sp>
-        <p:nvSpPr>
-          <p:cNvPr id="7" name="sources"/>
-          <p:cNvSpPr txBox="1"/>
-          <p:nvPr/>
-        </p:nvSpPr>
-        <p:spPr>
-          <a:xfrm>
-            <a:off x="502920" y="4700016"/>
-            <a:ext cx="8183879" cy="530352"/>
-          </a:xfrm>
-          <a:prstGeom prst="rect">
-            <a:avLst/>
-          </a:prstGeom>
-          <a:noFill/>
-        </p:spPr>
-        <p:txBody>
-          <a:bodyPr wrap="square" lIns="0" rIns="0" tIns="0" bIns="0">
-            <a:noAutofit/>
-          </a:bodyPr>
-          <a:lstStyle/>
-          <a:p>
-            <a:pPr algn="l">
-              <a:lnSpc>
-                <a:spcPts val="940"/>
-              </a:lnSpc>
-              <a:spcBef>
-                <a:spcPts val="0"/>
-              </a:spcBef>
-              <a:spcAft>
-                <a:spcPts val="140"/>
-              </a:spcAft>
-              <a:buNone/>
-              <a:defRPr sz="810" b="0">
-                <a:solidFill>
-                  <a:srgbClr val="303437"/>
-                </a:solidFill>
-                <a:latin typeface="Noto Sans"/>
-              </a:defRPr>
-            </a:pPr>
-            <a:r>
-              <a:rPr sz="810" b="0" lang="ja-JP" altLang="en-US">
-                <a:solidFill>
-                  <a:srgbClr val="626669"/>
-                </a:solidFill>
-                <a:latin typeface="Noto Sans"/>
-                <a:ea typeface="Noto Sans CJK JP"/>
-                <a:cs typeface="Noto Sans"/>
-              </a:rPr>
-              <a:t>[1] wmt/wmt14、改訂b199e406。2026-10-18参照。 ru-en / test行1。</a:t>
-            </a:r>
-            <a:r>
-              <a:rPr sz="810" b="0" lang="ja-JP" altLang="en-US">
-                <a:solidFill>
-                  <a:srgbClr val="626669"/>
-                </a:solidFill>
-                <a:latin typeface="Noto Sans"/>
-                <a:ea typeface="Noto Sans CJK JP"/>
-                <a:cs typeface="Noto Sans"/>
-              </a:rPr>
-              <a:t>  </a:t>
-            </a:r>
-            <a:r>
-              <a:rPr sz="810" b="0" lang="ja-JP" altLang="en-US">
-                <a:solidFill>
-                  <a:srgbClr val="626669"/>
-                </a:solidFill>
-                <a:latin typeface="Noto Sans"/>
-                <a:ea typeface="Noto Sans CJK JP"/>
-                <a:cs typeface="Noto Sans"/>
-                <a:hlinkClick r:id="rId2"/>
-              </a:rPr>
-              <a:t>https://huggingface.co/datasets/wmt/wmt14</a:t>
+              <a:t>Appendix: 2. 集計と評価条件</a:t>
             </a:r>
           </a:p>
         </p:txBody>
@@ -17886,45 +17731,128 @@
         </p:nvSpPr>
         <p:spPr>
           <a:xfrm>
-            <a:off x="548640" y="2506875"/>
-            <a:ext cx="8046720" cy="585216"/>
-          </a:xfrm>
-        </p:spPr>
-        <p:txBody>
-          <a:bodyPr wrap="square" lIns="0" rIns="0" tIns="0" bIns="0" anchor="ctr">
+            <a:off x="468172" y="650138"/>
+            <a:ext cx="8206740" cy="616305"/>
+          </a:xfrm>
+        </p:spPr>
+        <p:txBody>
+          <a:bodyPr wrap="square" lIns="0" rIns="0" tIns="0" bIns="0">
             <a:noAutofit/>
           </a:bodyPr>
           <a:lstStyle/>
           <a:p>
-            <a:pPr algn="ctr">
+            <a:pPr algn="l">
               <a:lnSpc>
                 <a:spcPct val="110000"/>
               </a:lnSpc>
               <a:buNone/>
-              <a:defRPr sz="3600" b="0">
-                <a:solidFill>
-                  <a:srgbClr val="303437"/>
-                </a:solidFill>
-                <a:latin typeface="Noto Sans"/>
-              </a:defRPr>
-            </a:pPr>
-            <a:r>
-              <a:rPr sz="3600" b="1" lang="ja-JP" altLang="en-US">
-                <a:solidFill>
-                  <a:srgbClr val="303437"/>
-                </a:solidFill>
-                <a:latin typeface="Noto Sans"/>
-                <a:ea typeface="Noto Sans CJK JP"/>
-                <a:cs typeface="Noto Sans"/>
-              </a:rPr>
-              <a:t>集計と評価条件</a:t>
-            </a:r>
-          </a:p>
-        </p:txBody>
-      </p:sp>
-      <p:sp>
-        <p:nvSpPr>
-          <p:cNvPr id="3" name="Title 2"/>
+              <a:defRPr sz="2800" b="0">
+                <a:solidFill>
+                  <a:srgbClr val="303437"/>
+                </a:solidFill>
+                <a:latin typeface="Noto Sans"/>
+              </a:defRPr>
+            </a:pPr>
+            <a:r>
+              <a:rPr sz="2800" b="1" lang="ja-JP" altLang="en-US">
+                <a:solidFill>
+                  <a:srgbClr val="303437"/>
+                </a:solidFill>
+                <a:latin typeface="Noto Sans"/>
+                <a:ea typeface="Noto Sans CJK JP"/>
+                <a:cs typeface="Noto Sans"/>
+              </a:rPr>
+              <a:t>同じニュースが、複数の言語組に現れる</a:t>
+            </a:r>
+          </a:p>
+        </p:txBody>
+      </p:sp>
+      <p:sp>
+        <p:nvSpPr>
+          <p:cNvPr id="3" name="Text Placeholder 2"/>
+          <p:cNvSpPr>
+            <a:spLocks noGrp="1"/>
+          </p:cNvSpPr>
+          <p:nvPr>
+            <p:ph type="body" idx="1"/>
+          </p:nvPr>
+        </p:nvSpPr>
+        <p:spPr>
+          <a:xfrm>
+            <a:off x="594360" y="1463040"/>
+            <a:ext cx="7955279" cy="3044952"/>
+          </a:xfrm>
+        </p:spPr>
+        <p:txBody>
+          <a:bodyPr wrap="square" tIns="91440" bIns="91440">
+            <a:noAutofit/>
+          </a:bodyPr>
+          <a:lstStyle/>
+          <a:p>
+            <a:pPr marL="457200" indent="-355600">
+              <a:lnSpc>
+                <a:spcPts val="2618"/>
+              </a:lnSpc>
+              <a:spcAft>
+                <a:spcPts val="700"/>
+              </a:spcAft>
+              <a:buSzPct val="60455"/>
+              <a:buFont typeface="Noto Sans CJK JP"/>
+              <a:buChar char="●"/>
+              <a:defRPr sz="2200" b="0">
+                <a:solidFill>
+                  <a:srgbClr val="303437"/>
+                </a:solidFill>
+                <a:latin typeface="Noto Sans"/>
+              </a:defRPr>
+            </a:pPr>
+            <a:r>
+              <a:rPr sz="2200" b="0" lang="ja-JP" altLang="en-US">
+                <a:solidFill>
+                  <a:srgbClr val="303437"/>
+                </a:solidFill>
+                <a:latin typeface="Noto Sans"/>
+                <a:ea typeface="Noto Sans CJK JP"/>
+                <a:cs typeface="Noto Sans"/>
+              </a:rPr>
+              <a:t>5言語組のtestを足すと14,519レコード。英語文が共通する組があるため、異なるニュース文の総数とは一致しない。</a:t>
+            </a:r>
+          </a:p>
+          <a:p>
+            <a:pPr marL="457200" indent="-355600">
+              <a:lnSpc>
+                <a:spcPts val="2618"/>
+              </a:lnSpc>
+              <a:spcAft>
+                <a:spcPts val="0"/>
+              </a:spcAft>
+              <a:buSzPct val="60455"/>
+              <a:buFont typeface="Noto Sans CJK JP"/>
+              <a:buChar char="●"/>
+              <a:defRPr sz="2200" b="0">
+                <a:solidFill>
+                  <a:srgbClr val="303437"/>
+                </a:solidFill>
+                <a:latin typeface="Noto Sans"/>
+              </a:defRPr>
+            </a:pPr>
+            <a:r>
+              <a:rPr sz="2200" b="0" lang="ja-JP" altLang="en-US">
+                <a:solidFill>
+                  <a:srgbClr val="303437"/>
+                </a:solidFill>
+                <a:latin typeface="Noto Sans"/>
+                <a:ea typeface="Noto Sans CJK JP"/>
+                <a:cs typeface="Noto Sans"/>
+              </a:rPr>
+              <a:t>掲載13例では、英語文が重ならないよう選んだ。対訳を日本語で説明し、英語を含む両言語の表現を原文として保持した。</a:t>
+            </a:r>
+          </a:p>
+        </p:txBody>
+      </p:sp>
+      <p:sp>
+        <p:nvSpPr>
+          <p:cNvPr id="4" name="Title 3"/>
           <p:cNvSpPr>
             <a:spLocks noGrp="1"/>
           </p:cNvSpPr>
@@ -17966,6 +17894,83 @@
                 <a:cs typeface="Noto Sans"/>
               </a:rPr>
               <a:t>Appendix: 2. 集計と評価条件</a:t>
+            </a:r>
+          </a:p>
+        </p:txBody>
+      </p:sp>
+      <p:sp>
+        <p:nvSpPr>
+          <p:cNvPr id="5" name="sources"/>
+          <p:cNvSpPr txBox="1"/>
+          <p:nvPr/>
+        </p:nvSpPr>
+        <p:spPr>
+          <a:xfrm>
+            <a:off x="502920" y="4700016"/>
+            <a:ext cx="8183879" cy="530352"/>
+          </a:xfrm>
+          <a:prstGeom prst="rect">
+            <a:avLst/>
+          </a:prstGeom>
+          <a:noFill/>
+        </p:spPr>
+        <p:txBody>
+          <a:bodyPr wrap="square" lIns="0" rIns="0" tIns="0" bIns="0">
+            <a:noAutofit/>
+          </a:bodyPr>
+          <a:lstStyle/>
+          <a:p>
+            <a:pPr algn="l">
+              <a:lnSpc>
+                <a:spcPts val="940"/>
+              </a:lnSpc>
+              <a:spcBef>
+                <a:spcPts val="0"/>
+              </a:spcBef>
+              <a:spcAft>
+                <a:spcPts val="140"/>
+              </a:spcAft>
+              <a:buNone/>
+              <a:defRPr sz="810" b="0">
+                <a:solidFill>
+                  <a:srgbClr val="303437"/>
+                </a:solidFill>
+                <a:latin typeface="Noto Sans"/>
+              </a:defRPr>
+            </a:pPr>
+            <a:r>
+              <a:rPr sz="810" b="0" lang="ja-JP" altLang="en-US">
+                <a:solidFill>
+                  <a:srgbClr val="626669"/>
+                </a:solidFill>
+                <a:latin typeface="Noto Sans"/>
+                <a:ea typeface="Noto Sans CJK JP"/>
+                <a:cs typeface="Noto Sans"/>
+              </a:rPr>
+              <a:t>[1] WMT14、five language pairs/test全14,519件を集計。2026-10-18取得。</a:t>
+            </a:r>
+            <a:r>
+              <a:rPr sz="810" b="0" lang="ja-JP" altLang="en-US">
+                <a:solidFill>
+                  <a:srgbClr val="626669"/>
+                </a:solidFill>
+                <a:latin typeface="Noto Sans"/>
+                <a:ea typeface="Noto Sans CJK JP"/>
+                <a:cs typeface="Noto Sans"/>
+              </a:rPr>
+              <a:t>  </a:t>
+            </a:r>
+            <a:r>
+              <a:rPr sz="810" b="0" lang="ja-JP" altLang="en-US">
+                <a:solidFill>
+                  <a:srgbClr val="626669"/>
+                </a:solidFill>
+                <a:latin typeface="Noto Sans"/>
+                <a:ea typeface="Noto Sans CJK JP"/>
+                <a:cs typeface="Noto Sans"/>
+                <a:hlinkClick r:id="rId2"/>
+              </a:rPr>
+              <a:t>https://huggingface.co/datasets/wmt/wmt14</a:t>
             </a:r>
           </a:p>
         </p:txBody>
@@ -18000,128 +18005,45 @@
         </p:nvSpPr>
         <p:spPr>
           <a:xfrm>
-            <a:off x="468172" y="650138"/>
-            <a:ext cx="8206740" cy="616305"/>
-          </a:xfrm>
-        </p:spPr>
-        <p:txBody>
-          <a:bodyPr wrap="square" lIns="0" rIns="0" tIns="0" bIns="0">
+            <a:off x="548640" y="2506875"/>
+            <a:ext cx="8046720" cy="585216"/>
+          </a:xfrm>
+        </p:spPr>
+        <p:txBody>
+          <a:bodyPr wrap="square" lIns="0" rIns="0" tIns="0" bIns="0" anchor="ctr">
             <a:noAutofit/>
           </a:bodyPr>
           <a:lstStyle/>
           <a:p>
-            <a:pPr algn="l">
+            <a:pPr algn="ctr">
               <a:lnSpc>
                 <a:spcPct val="110000"/>
               </a:lnSpc>
               <a:buNone/>
-              <a:defRPr sz="2800" b="0">
-                <a:solidFill>
-                  <a:srgbClr val="303437"/>
-                </a:solidFill>
-                <a:latin typeface="Noto Sans"/>
-              </a:defRPr>
-            </a:pPr>
-            <a:r>
-              <a:rPr sz="2800" b="1" lang="ja-JP" altLang="en-US">
-                <a:solidFill>
-                  <a:srgbClr val="303437"/>
-                </a:solidFill>
-                <a:latin typeface="Noto Sans"/>
-                <a:ea typeface="Noto Sans CJK JP"/>
-                <a:cs typeface="Noto Sans"/>
-              </a:rPr>
-              <a:t>同じニュースが、複数の言語組に現れる</a:t>
-            </a:r>
-          </a:p>
-        </p:txBody>
-      </p:sp>
-      <p:sp>
-        <p:nvSpPr>
-          <p:cNvPr id="3" name="Text Placeholder 2"/>
-          <p:cNvSpPr>
-            <a:spLocks noGrp="1"/>
-          </p:cNvSpPr>
-          <p:nvPr>
-            <p:ph type="body" idx="1"/>
-          </p:nvPr>
-        </p:nvSpPr>
-        <p:spPr>
-          <a:xfrm>
-            <a:off x="594360" y="1463040"/>
-            <a:ext cx="7955279" cy="3044952"/>
-          </a:xfrm>
-        </p:spPr>
-        <p:txBody>
-          <a:bodyPr wrap="square" tIns="91440" bIns="91440">
-            <a:noAutofit/>
-          </a:bodyPr>
-          <a:lstStyle/>
-          <a:p>
-            <a:pPr marL="457200" indent="-355600">
-              <a:lnSpc>
-                <a:spcPts val="2618"/>
-              </a:lnSpc>
-              <a:spcAft>
-                <a:spcPts val="700"/>
-              </a:spcAft>
-              <a:buSzPct val="60455"/>
-              <a:buFont typeface="Noto Sans CJK JP"/>
-              <a:buChar char="●"/>
-              <a:defRPr sz="2200" b="0">
-                <a:solidFill>
-                  <a:srgbClr val="303437"/>
-                </a:solidFill>
-                <a:latin typeface="Noto Sans"/>
-              </a:defRPr>
-            </a:pPr>
-            <a:r>
-              <a:rPr sz="2200" b="0" lang="ja-JP" altLang="en-US">
-                <a:solidFill>
-                  <a:srgbClr val="303437"/>
-                </a:solidFill>
-                <a:latin typeface="Noto Sans"/>
-                <a:ea typeface="Noto Sans CJK JP"/>
-                <a:cs typeface="Noto Sans"/>
-              </a:rPr>
-              <a:t>5言語組のtestを足すと14,519レコード。英語文が共通する組があるため、異なるニュース文の総数とは一致しない。</a:t>
-            </a:r>
-          </a:p>
-          <a:p>
-            <a:pPr marL="457200" indent="-355600">
-              <a:lnSpc>
-                <a:spcPts val="2618"/>
-              </a:lnSpc>
-              <a:spcAft>
-                <a:spcPts val="0"/>
-              </a:spcAft>
-              <a:buSzPct val="60455"/>
-              <a:buFont typeface="Noto Sans CJK JP"/>
-              <a:buChar char="●"/>
-              <a:defRPr sz="2200" b="0">
-                <a:solidFill>
-                  <a:srgbClr val="303437"/>
-                </a:solidFill>
-                <a:latin typeface="Noto Sans"/>
-              </a:defRPr>
-            </a:pPr>
-            <a:r>
-              <a:rPr sz="2200" b="0" lang="ja-JP" altLang="en-US">
-                <a:solidFill>
-                  <a:srgbClr val="303437"/>
-                </a:solidFill>
-                <a:latin typeface="Noto Sans"/>
-                <a:ea typeface="Noto Sans CJK JP"/>
-                <a:cs typeface="Noto Sans"/>
-              </a:rPr>
-              <a:t>掲載13例では、英語文が重ならないよう選んだ。対訳を日本語で説明し、英語を含む両言語の表現を原文として保持した。</a:t>
-            </a:r>
-          </a:p>
-        </p:txBody>
-      </p:sp>
-      <p:sp>
-        <p:nvSpPr>
-          <p:cNvPr id="4" name="Title 3"/>
+              <a:defRPr sz="3600" b="0">
+                <a:solidFill>
+                  <a:srgbClr val="303437"/>
+                </a:solidFill>
+                <a:latin typeface="Noto Sans"/>
+              </a:defRPr>
+            </a:pPr>
+            <a:r>
+              <a:rPr sz="3600" b="1" lang="ja-JP" altLang="en-US">
+                <a:solidFill>
+                  <a:srgbClr val="303437"/>
+                </a:solidFill>
+                <a:latin typeface="Noto Sans"/>
+                <a:ea typeface="Noto Sans CJK JP"/>
+                <a:cs typeface="Noto Sans"/>
+              </a:rPr>
+              <a:t>研究と参考文献</a:t>
+            </a:r>
+          </a:p>
+        </p:txBody>
+      </p:sp>
+      <p:sp>
+        <p:nvSpPr>
+          <p:cNvPr id="3" name="Title 2"/>
           <p:cNvSpPr>
             <a:spLocks noGrp="1"/>
           </p:cNvSpPr>
@@ -18162,84 +18084,7 @@
                 <a:ea typeface="Noto Sans CJK JP"/>
                 <a:cs typeface="Noto Sans"/>
               </a:rPr>
-              <a:t>Appendix: 2. 集計と評価条件</a:t>
-            </a:r>
-          </a:p>
-        </p:txBody>
-      </p:sp>
-      <p:sp>
-        <p:nvSpPr>
-          <p:cNvPr id="5" name="sources"/>
-          <p:cNvSpPr txBox="1"/>
-          <p:nvPr/>
-        </p:nvSpPr>
-        <p:spPr>
-          <a:xfrm>
-            <a:off x="502920" y="4700016"/>
-            <a:ext cx="8183879" cy="530352"/>
-          </a:xfrm>
-          <a:prstGeom prst="rect">
-            <a:avLst/>
-          </a:prstGeom>
-          <a:noFill/>
-        </p:spPr>
-        <p:txBody>
-          <a:bodyPr wrap="square" lIns="0" rIns="0" tIns="0" bIns="0">
-            <a:noAutofit/>
-          </a:bodyPr>
-          <a:lstStyle/>
-          <a:p>
-            <a:pPr algn="l">
-              <a:lnSpc>
-                <a:spcPts val="940"/>
-              </a:lnSpc>
-              <a:spcBef>
-                <a:spcPts val="0"/>
-              </a:spcBef>
-              <a:spcAft>
-                <a:spcPts val="140"/>
-              </a:spcAft>
-              <a:buNone/>
-              <a:defRPr sz="810" b="0">
-                <a:solidFill>
-                  <a:srgbClr val="303437"/>
-                </a:solidFill>
-                <a:latin typeface="Noto Sans"/>
-              </a:defRPr>
-            </a:pPr>
-            <a:r>
-              <a:rPr sz="810" b="0" lang="ja-JP" altLang="en-US">
-                <a:solidFill>
-                  <a:srgbClr val="626669"/>
-                </a:solidFill>
-                <a:latin typeface="Noto Sans"/>
-                <a:ea typeface="Noto Sans CJK JP"/>
-                <a:cs typeface="Noto Sans"/>
-              </a:rPr>
-              <a:t>[1] WMT14、five language pairs/test全14,519件を集計。2026-10-18取得。</a:t>
-            </a:r>
-            <a:r>
-              <a:rPr sz="810" b="0" lang="ja-JP" altLang="en-US">
-                <a:solidFill>
-                  <a:srgbClr val="626669"/>
-                </a:solidFill>
-                <a:latin typeface="Noto Sans"/>
-                <a:ea typeface="Noto Sans CJK JP"/>
-                <a:cs typeface="Noto Sans"/>
-              </a:rPr>
-              <a:t>  </a:t>
-            </a:r>
-            <a:r>
-              <a:rPr sz="810" b="0" lang="ja-JP" altLang="en-US">
-                <a:solidFill>
-                  <a:srgbClr val="626669"/>
-                </a:solidFill>
-                <a:latin typeface="Noto Sans"/>
-                <a:ea typeface="Noto Sans CJK JP"/>
-                <a:cs typeface="Noto Sans"/>
-                <a:hlinkClick r:id="rId2"/>
-              </a:rPr>
-              <a:t>https://huggingface.co/datasets/wmt/wmt14</a:t>
+              <a:t>Appendix: 3. 研究と参考文献</a:t>
             </a:r>
           </a:p>
         </p:txBody>
@@ -18388,45 +18233,128 @@
         </p:nvSpPr>
         <p:spPr>
           <a:xfrm>
-            <a:off x="548640" y="2506875"/>
-            <a:ext cx="8046720" cy="585216"/>
-          </a:xfrm>
-        </p:spPr>
-        <p:txBody>
-          <a:bodyPr wrap="square" lIns="0" rIns="0" tIns="0" bIns="0" anchor="ctr">
+            <a:off x="468172" y="650138"/>
+            <a:ext cx="8206740" cy="616305"/>
+          </a:xfrm>
+        </p:spPr>
+        <p:txBody>
+          <a:bodyPr wrap="square" lIns="0" rIns="0" tIns="0" bIns="0">
             <a:noAutofit/>
           </a:bodyPr>
           <a:lstStyle/>
           <a:p>
-            <a:pPr algn="ctr">
+            <a:pPr algn="l">
               <a:lnSpc>
                 <a:spcPct val="110000"/>
               </a:lnSpc>
               <a:buNone/>
-              <a:defRPr sz="3600" b="0">
-                <a:solidFill>
-                  <a:srgbClr val="303437"/>
-                </a:solidFill>
-                <a:latin typeface="Noto Sans"/>
-              </a:defRPr>
-            </a:pPr>
-            <a:r>
-              <a:rPr sz="3600" b="1" lang="ja-JP" altLang="en-US">
-                <a:solidFill>
-                  <a:srgbClr val="303437"/>
-                </a:solidFill>
-                <a:latin typeface="Noto Sans"/>
-                <a:ea typeface="Noto Sans CJK JP"/>
-                <a:cs typeface="Noto Sans"/>
-              </a:rPr>
-              <a:t>研究と参考文献</a:t>
-            </a:r>
-          </a:p>
-        </p:txBody>
-      </p:sp>
-      <p:sp>
-        <p:nvSpPr>
-          <p:cNvPr id="3" name="Title 2"/>
+              <a:defRPr sz="2800" b="0">
+                <a:solidFill>
+                  <a:srgbClr val="303437"/>
+                </a:solidFill>
+                <a:latin typeface="Noto Sans"/>
+              </a:defRPr>
+            </a:pPr>
+            <a:r>
+              <a:rPr sz="2800" b="1" lang="ja-JP" altLang="en-US">
+                <a:solidFill>
+                  <a:srgbClr val="303437"/>
+                </a:solidFill>
+                <a:latin typeface="Noto Sans"/>
+                <a:ea typeface="Noto Sans CJK JP"/>
+                <a:cs typeface="Noto Sans"/>
+              </a:rPr>
+              <a:t>研究者と発表の位置付け</a:t>
+            </a:r>
+          </a:p>
+        </p:txBody>
+      </p:sp>
+      <p:sp>
+        <p:nvSpPr>
+          <p:cNvPr id="3" name="Text Placeholder 2"/>
+          <p:cNvSpPr>
+            <a:spLocks noGrp="1"/>
+          </p:cNvSpPr>
+          <p:nvPr>
+            <p:ph type="body" idx="1"/>
+          </p:nvPr>
+        </p:nvSpPr>
+        <p:spPr>
+          <a:xfrm>
+            <a:off x="594360" y="1463040"/>
+            <a:ext cx="7955279" cy="3044952"/>
+          </a:xfrm>
+        </p:spPr>
+        <p:txBody>
+          <a:bodyPr wrap="square" tIns="91440" bIns="91440">
+            <a:noAutofit/>
+          </a:bodyPr>
+          <a:lstStyle/>
+          <a:p>
+            <a:pPr marL="457200" indent="-355600">
+              <a:lnSpc>
+                <a:spcPts val="2618"/>
+              </a:lnSpc>
+              <a:spcAft>
+                <a:spcPts val="700"/>
+              </a:spcAft>
+              <a:buSzPct val="60455"/>
+              <a:buFont typeface="Noto Sans CJK JP"/>
+              <a:buChar char="●"/>
+              <a:defRPr sz="2200" b="0">
+                <a:solidFill>
+                  <a:srgbClr val="303437"/>
+                </a:solidFill>
+                <a:latin typeface="Noto Sans"/>
+              </a:defRPr>
+            </a:pPr>
+            <a:r>
+              <a:rPr sz="2200" b="0" lang="ja-JP" altLang="en-US">
+                <a:solidFill>
+                  <a:srgbClr val="303437"/>
+                </a:solidFill>
+                <a:latin typeface="Noto Sans"/>
+                <a:ea typeface="Noto Sans CJK JP"/>
+                <a:cs typeface="Noto Sans"/>
+              </a:rPr>
+              <a:t>WMT 2014の報告は、第一著者Ondřej Bojar、最終著者Aleš Tamchynaら、13名の運営者による共同研究。</a:t>
+            </a:r>
+          </a:p>
+          <a:p>
+            <a:pPr marL="457200" indent="-355600">
+              <a:lnSpc>
+                <a:spcPts val="2618"/>
+              </a:lnSpc>
+              <a:spcAft>
+                <a:spcPts val="0"/>
+              </a:spcAft>
+              <a:buSzPct val="60455"/>
+              <a:buFont typeface="Noto Sans CJK JP"/>
+              <a:buChar char="●"/>
+              <a:defRPr sz="2200" b="0">
+                <a:solidFill>
+                  <a:srgbClr val="303437"/>
+                </a:solidFill>
+                <a:latin typeface="Noto Sans"/>
+              </a:defRPr>
+            </a:pPr>
+            <a:r>
+              <a:rPr sz="2200" b="0" lang="ja-JP" altLang="en-US">
+                <a:solidFill>
+                  <a:srgbClr val="303437"/>
+                </a:solidFill>
+                <a:latin typeface="Noto Sans"/>
+                <a:ea typeface="Noto Sans CJK JP"/>
+                <a:cs typeface="Noto Sans"/>
+              </a:rPr>
+              <a:t>Charles University、University of Edinburghなどの研究者が、翻訳タスクの資源、人手評価、システム比較をまとめた。</a:t>
+            </a:r>
+          </a:p>
+        </p:txBody>
+      </p:sp>
+      <p:sp>
+        <p:nvSpPr>
+          <p:cNvPr id="4" name="Title 3"/>
           <p:cNvSpPr>
             <a:spLocks noGrp="1"/>
           </p:cNvSpPr>
@@ -18468,6 +18396,83 @@
                 <a:cs typeface="Noto Sans"/>
               </a:rPr>
               <a:t>Appendix: 3. 研究と参考文献</a:t>
+            </a:r>
+          </a:p>
+        </p:txBody>
+      </p:sp>
+      <p:sp>
+        <p:nvSpPr>
+          <p:cNvPr id="5" name="sources"/>
+          <p:cNvSpPr txBox="1"/>
+          <p:nvPr/>
+        </p:nvSpPr>
+        <p:spPr>
+          <a:xfrm>
+            <a:off x="502920" y="4700016"/>
+            <a:ext cx="8183879" cy="530352"/>
+          </a:xfrm>
+          <a:prstGeom prst="rect">
+            <a:avLst/>
+          </a:prstGeom>
+          <a:noFill/>
+        </p:spPr>
+        <p:txBody>
+          <a:bodyPr wrap="square" lIns="0" rIns="0" tIns="0" bIns="0">
+            <a:noAutofit/>
+          </a:bodyPr>
+          <a:lstStyle/>
+          <a:p>
+            <a:pPr algn="l">
+              <a:lnSpc>
+                <a:spcPts val="940"/>
+              </a:lnSpc>
+              <a:spcBef>
+                <a:spcPts val="0"/>
+              </a:spcBef>
+              <a:spcAft>
+                <a:spcPts val="140"/>
+              </a:spcAft>
+              <a:buNone/>
+              <a:defRPr sz="810" b="0">
+                <a:solidFill>
+                  <a:srgbClr val="303437"/>
+                </a:solidFill>
+                <a:latin typeface="Noto Sans"/>
+              </a:defRPr>
+            </a:pPr>
+            <a:r>
+              <a:rPr sz="810" b="0" lang="ja-JP" altLang="en-US">
+                <a:solidFill>
+                  <a:srgbClr val="626669"/>
+                </a:solidFill>
+                <a:latin typeface="Noto Sans"/>
+                <a:ea typeface="Noto Sans CJK JP"/>
+                <a:cs typeface="Noto Sans"/>
+              </a:rPr>
+              <a:t>[1] Ondřej Bojar et al. (2014). Findings of the 2014 Workshop on Statistical Machine Translation. WMT 2014.</a:t>
+            </a:r>
+            <a:r>
+              <a:rPr sz="810" b="0" lang="ja-JP" altLang="en-US">
+                <a:solidFill>
+                  <a:srgbClr val="626669"/>
+                </a:solidFill>
+                <a:latin typeface="Noto Sans"/>
+                <a:ea typeface="Noto Sans CJK JP"/>
+                <a:cs typeface="Noto Sans"/>
+              </a:rPr>
+              <a:t>  </a:t>
+            </a:r>
+            <a:r>
+              <a:rPr sz="810" b="0" lang="ja-JP" altLang="en-US">
+                <a:solidFill>
+                  <a:srgbClr val="626669"/>
+                </a:solidFill>
+                <a:latin typeface="Noto Sans"/>
+                <a:ea typeface="Noto Sans CJK JP"/>
+                <a:cs typeface="Noto Sans"/>
+                <a:hlinkClick r:id="rId2"/>
+              </a:rPr>
+              <a:t>https://aclanthology.org/W14-3302/</a:t>
             </a:r>
           </a:p>
         </p:txBody>
@@ -18533,97 +18538,14 @@
                 <a:ea typeface="Noto Sans CJK JP"/>
                 <a:cs typeface="Noto Sans"/>
               </a:rPr>
-              <a:t>研究者と発表の位置付け</a:t>
-            </a:r>
-          </a:p>
-        </p:txBody>
-      </p:sp>
-      <p:sp>
-        <p:nvSpPr>
-          <p:cNvPr id="3" name="Text Placeholder 2"/>
-          <p:cNvSpPr>
-            <a:spLocks noGrp="1"/>
-          </p:cNvSpPr>
-          <p:nvPr>
-            <p:ph type="body" idx="1"/>
-          </p:nvPr>
-        </p:nvSpPr>
-        <p:spPr>
-          <a:xfrm>
-            <a:off x="594360" y="1463040"/>
-            <a:ext cx="7955279" cy="3044952"/>
-          </a:xfrm>
-        </p:spPr>
-        <p:txBody>
-          <a:bodyPr wrap="square" tIns="91440" bIns="91440">
-            <a:noAutofit/>
-          </a:bodyPr>
-          <a:lstStyle/>
-          <a:p>
-            <a:pPr marL="457200" indent="-355600">
-              <a:lnSpc>
-                <a:spcPts val="2618"/>
-              </a:lnSpc>
-              <a:spcAft>
-                <a:spcPts val="700"/>
-              </a:spcAft>
-              <a:buSzPct val="60455"/>
-              <a:buFont typeface="Noto Sans CJK JP"/>
-              <a:buChar char="●"/>
-              <a:defRPr sz="2200" b="0">
-                <a:solidFill>
-                  <a:srgbClr val="303437"/>
-                </a:solidFill>
-                <a:latin typeface="Noto Sans"/>
-              </a:defRPr>
-            </a:pPr>
-            <a:r>
-              <a:rPr sz="2200" b="0" lang="ja-JP" altLang="en-US">
-                <a:solidFill>
-                  <a:srgbClr val="303437"/>
-                </a:solidFill>
-                <a:latin typeface="Noto Sans"/>
-                <a:ea typeface="Noto Sans CJK JP"/>
-                <a:cs typeface="Noto Sans"/>
-              </a:rPr>
-              <a:t>WMT 2014の報告は、第一著者Ondřej Bojar、最終著者Aleš Tamchynaら、13名の運営者による共同研究。</a:t>
-            </a:r>
-          </a:p>
-          <a:p>
-            <a:pPr marL="457200" indent="-355600">
-              <a:lnSpc>
-                <a:spcPts val="2618"/>
-              </a:lnSpc>
-              <a:spcAft>
-                <a:spcPts val="0"/>
-              </a:spcAft>
-              <a:buSzPct val="60455"/>
-              <a:buFont typeface="Noto Sans CJK JP"/>
-              <a:buChar char="●"/>
-              <a:defRPr sz="2200" b="0">
-                <a:solidFill>
-                  <a:srgbClr val="303437"/>
-                </a:solidFill>
-                <a:latin typeface="Noto Sans"/>
-              </a:defRPr>
-            </a:pPr>
-            <a:r>
-              <a:rPr sz="2200" b="0" lang="ja-JP" altLang="en-US">
-                <a:solidFill>
-                  <a:srgbClr val="303437"/>
-                </a:solidFill>
-                <a:latin typeface="Noto Sans"/>
-                <a:ea typeface="Noto Sans CJK JP"/>
-                <a:cs typeface="Noto Sans"/>
-              </a:rPr>
-              <a:t>Charles University、University of Edinburghなどの研究者が、翻訳タスクの資源、人手評価、システム比較をまとめた。</a:t>
-            </a:r>
-          </a:p>
-        </p:txBody>
-      </p:sp>
-      <p:sp>
-        <p:nvSpPr>
-          <p:cNvPr id="4" name="Title 3"/>
+              <a:t>参考文献</a:t>
+            </a:r>
+          </a:p>
+        </p:txBody>
+      </p:sp>
+      <p:sp>
+        <p:nvSpPr>
+          <p:cNvPr id="3" name="Title 2"/>
           <p:cNvSpPr>
             <a:spLocks noGrp="1"/>
           </p:cNvSpPr>
@@ -18671,14 +18593,14 @@
       </p:sp>
       <p:sp>
         <p:nvSpPr>
-          <p:cNvPr id="5" name="sources"/>
+          <p:cNvPr id="4" name="文献 1: Findings of the 2014 Workshop on Statistical Machine Translation"/>
           <p:cNvSpPr txBox="1"/>
           <p:nvPr/>
         </p:nvSpPr>
         <p:spPr>
           <a:xfrm>
-            <a:off x="502920" y="4700016"/>
-            <a:ext cx="8183879" cy="530352"/>
+            <a:off x="548640" y="1463040"/>
+            <a:ext cx="8046720" cy="3200400"/>
           </a:xfrm>
           <a:prstGeom prst="rect">
             <a:avLst/>
@@ -18693,24 +18615,55 @@
           <a:p>
             <a:pPr algn="l">
               <a:lnSpc>
-                <a:spcPts val="940"/>
-              </a:lnSpc>
-              <a:spcBef>
-                <a:spcPts val="0"/>
-              </a:spcBef>
-              <a:spcAft>
-                <a:spcPts val="140"/>
-              </a:spcAft>
-              <a:buNone/>
-              <a:defRPr sz="810" b="0">
-                <a:solidFill>
-                  <a:srgbClr val="303437"/>
-                </a:solidFill>
-                <a:latin typeface="Noto Sans"/>
-              </a:defRPr>
-            </a:pPr>
-            <a:r>
-              <a:rPr sz="810" b="0" lang="ja-JP" altLang="en-US">
+                <a:spcPct val="114000"/>
+              </a:lnSpc>
+              <a:spcBef>
+                <a:spcPts val="0"/>
+              </a:spcBef>
+              <a:spcAft>
+                <a:spcPts val="400"/>
+              </a:spcAft>
+              <a:buNone/>
+              <a:defRPr sz="2000" b="0">
+                <a:solidFill>
+                  <a:srgbClr val="303437"/>
+                </a:solidFill>
+                <a:latin typeface="Noto Sans"/>
+              </a:defRPr>
+            </a:pPr>
+            <a:r>
+              <a:rPr sz="2000" b="1" lang="ja-JP" altLang="en-US">
+                <a:solidFill>
+                  <a:srgbClr val="303437"/>
+                </a:solidFill>
+                <a:latin typeface="Noto Sans"/>
+                <a:ea typeface="Noto Sans CJK JP"/>
+                <a:cs typeface="Noto Sans"/>
+              </a:rPr>
+              <a:t>Findings of the 2014 Workshop on Statistical Machine Translation</a:t>
+            </a:r>
+          </a:p>
+          <a:p>
+            <a:pPr algn="l">
+              <a:lnSpc>
+                <a:spcPct val="114000"/>
+              </a:lnSpc>
+              <a:spcBef>
+                <a:spcPts val="0"/>
+              </a:spcBef>
+              <a:spcAft>
+                <a:spcPts val="500"/>
+              </a:spcAft>
+              <a:buNone/>
+              <a:defRPr sz="1350" b="0">
+                <a:solidFill>
+                  <a:srgbClr val="303437"/>
+                </a:solidFill>
+                <a:latin typeface="Noto Sans"/>
+              </a:defRPr>
+            </a:pPr>
+            <a:r>
+              <a:rPr sz="1350" b="0" lang="ja-JP" altLang="en-US">
                 <a:solidFill>
                   <a:srgbClr val="626669"/>
                 </a:solidFill>
@@ -18718,21 +18671,61 @@
                 <a:ea typeface="Noto Sans CJK JP"/>
                 <a:cs typeface="Noto Sans"/>
               </a:rPr>
-              <a:t>[1] Ondřej Bojar et al. (2014). Findings of the 2014 Workshop on Statistical Machine Translation. WMT 2014.</a:t>
-            </a:r>
-            <a:r>
-              <a:rPr sz="810" b="0" lang="ja-JP" altLang="en-US">
-                <a:solidFill>
-                  <a:srgbClr val="626669"/>
-                </a:solidFill>
-                <a:latin typeface="Noto Sans"/>
-                <a:ea typeface="Noto Sans CJK JP"/>
-                <a:cs typeface="Noto Sans"/>
-              </a:rPr>
-              <a:t>  </a:t>
-            </a:r>
-            <a:r>
-              <a:rPr sz="810" b="0" lang="ja-JP" altLang="en-US">
+              <a:t>Ondřej Bojar, Christian Buck, Christian Federmann, Barry Haddow, Philipp Koehn, Johannes Leveling, Christof Monz, Pavel Pecina, Matt Post, Herve Saint-Amand, Radu Soricut, Lucia Specia, Aleš Tamchyna / WMT 2014</a:t>
+            </a:r>
+          </a:p>
+          <a:p>
+            <a:pPr algn="l">
+              <a:lnSpc>
+                <a:spcPct val="114000"/>
+              </a:lnSpc>
+              <a:spcBef>
+                <a:spcPts val="0"/>
+              </a:spcBef>
+              <a:spcAft>
+                <a:spcPts val="400"/>
+              </a:spcAft>
+              <a:buNone/>
+              <a:defRPr sz="1850" b="0">
+                <a:solidFill>
+                  <a:srgbClr val="303437"/>
+                </a:solidFill>
+                <a:latin typeface="Noto Sans"/>
+              </a:defRPr>
+            </a:pPr>
+            <a:r>
+              <a:rPr sz="1850" b="0" lang="ja-JP" altLang="en-US">
+                <a:solidFill>
+                  <a:srgbClr val="303437"/>
+                </a:solidFill>
+                <a:latin typeface="Noto Sans"/>
+                <a:ea typeface="Noto Sans CJK JP"/>
+                <a:cs typeface="Noto Sans"/>
+              </a:rPr>
+              <a:t>WMT14の目的、作成方法、評価をまとめた研究。</a:t>
+            </a:r>
+          </a:p>
+          <a:p>
+            <a:pPr algn="l">
+              <a:lnSpc>
+                <a:spcPct val="114000"/>
+              </a:lnSpc>
+              <a:spcBef>
+                <a:spcPts val="0"/>
+              </a:spcBef>
+              <a:spcAft>
+                <a:spcPts val="0"/>
+              </a:spcAft>
+              <a:buNone/>
+              <a:defRPr sz="1150" b="0">
+                <a:solidFill>
+                  <a:srgbClr val="303437"/>
+                </a:solidFill>
+                <a:latin typeface="Noto Sans"/>
+              </a:defRPr>
+            </a:pPr>
+            <a:r>
+              <a:rPr sz="1150" b="0" lang="ja-JP" altLang="en-US">
                 <a:solidFill>
                   <a:srgbClr val="626669"/>
                 </a:solidFill>
@@ -18862,7 +18855,7 @@
       </p:sp>
       <p:sp>
         <p:nvSpPr>
-          <p:cNvPr id="4" name="文献 1: Findings of the 2014 Workshop on Statistical Machine Translation"/>
+          <p:cNvPr id="4" name="文献 1: Holistic Evaluation of Language Models"/>
           <p:cNvSpPr txBox="1"/>
           <p:nvPr/>
         </p:nvSpPr>
@@ -18909,7 +18902,7 @@
                 <a:ea typeface="Noto Sans CJK JP"/>
                 <a:cs typeface="Noto Sans"/>
               </a:rPr>
-              <a:t>Findings of the 2014 Workshop on Statistical Machine Translation</a:t>
+              <a:t>Holistic Evaluation of Language Models</a:t>
             </a:r>
           </a:p>
           <a:p>
@@ -18940,7 +18933,7 @@
                 <a:ea typeface="Noto Sans CJK JP"/>
                 <a:cs typeface="Noto Sans"/>
               </a:rPr>
-              <a:t>Ondřej Bojar, Christian Buck, Christian Federmann, Barry Haddow, Philipp Koehn, Johannes Leveling, Christof Monz, Pavel Pecina, Matt Post, Herve Saint-Amand, Radu Soricut, Lucia Specia, Aleš Tamchyna / WMT 2014</a:t>
+              <a:t>Percy Liang et al. / TMLR 2023</a:t>
             </a:r>
           </a:p>
           <a:p>
@@ -18971,7 +18964,7 @@
                 <a:ea typeface="Noto Sans CJK JP"/>
                 <a:cs typeface="Noto Sans"/>
               </a:rPr>
-              <a:t>WMT14の目的、作成方法、評価をまとめた研究。</a:t>
+              <a:t>複数のシナリオと指標で、言語モデルを比較するHELMの研究。</a:t>
             </a:r>
           </a:p>
           <a:p>
@@ -19003,7 +18996,7 @@
                 <a:cs typeface="Noto Sans"/>
                 <a:hlinkClick r:id="rId2"/>
               </a:rPr>
-              <a:t>https://aclanthology.org/W14-3302/</a:t>
+              <a:t>https://arxiv.org/abs/2211.09110</a:t>
             </a:r>
           </a:p>
         </p:txBody>
@@ -19124,7 +19117,7 @@
       </p:sp>
       <p:sp>
         <p:nvSpPr>
-          <p:cNvPr id="4" name="文献 1: Holistic Evaluation of Language Models"/>
+          <p:cNvPr id="4" name="文献 1: WMT14：公開データ"/>
           <p:cNvSpPr txBox="1"/>
           <p:nvPr/>
         </p:nvSpPr>
@@ -19171,7 +19164,7 @@
                 <a:ea typeface="Noto Sans CJK JP"/>
                 <a:cs typeface="Noto Sans"/>
               </a:rPr>
-              <a:t>Holistic Evaluation of Language Models</a:t>
+              <a:t>WMT14：公開データ</a:t>
             </a:r>
           </a:p>
           <a:p>
@@ -19202,7 +19195,7 @@
                 <a:ea typeface="Noto Sans CJK JP"/>
                 <a:cs typeface="Noto Sans"/>
               </a:rPr>
-              <a:t>Percy Liang et al. / TMLR 2023</a:t>
+              <a:t>wmt/wmt14 / 改訂b199e406 / 2026-10-18参照</a:t>
             </a:r>
           </a:p>
           <a:p>
@@ -19233,7 +19226,7 @@
                 <a:ea typeface="Noto Sans CJK JP"/>
                 <a:cs typeface="Noto Sans"/>
               </a:rPr>
-              <a:t>複数のシナリオと指標で、言語モデルを比較するHELMの研究。</a:t>
+              <a:t>掲載した13件の対訳と、言語組ごとの全件集計に用いた公開資源。</a:t>
             </a:r>
           </a:p>
           <a:p>
@@ -19265,7 +19258,7 @@
                 <a:cs typeface="Noto Sans"/>
                 <a:hlinkClick r:id="rId2"/>
               </a:rPr>
-              <a:t>https://arxiv.org/abs/2211.09110</a:t>
+              <a:t>https://huggingface.co/datasets/wmt/wmt14</a:t>
             </a:r>
           </a:p>
         </p:txBody>
@@ -19386,7 +19379,7 @@
       </p:sp>
       <p:sp>
         <p:nvSpPr>
-          <p:cNvPr id="4" name="文献 1: WMT14：公開データ"/>
+          <p:cNvPr id="4" name="文献 1: Google's Neural Machine Translation System: Bridging the Gap between Human and Machine Translation"/>
           <p:cNvSpPr txBox="1"/>
           <p:nvPr/>
         </p:nvSpPr>
@@ -19433,7 +19426,7 @@
                 <a:ea typeface="Noto Sans CJK JP"/>
                 <a:cs typeface="Noto Sans"/>
               </a:rPr>
-              <a:t>WMT14：公開データ</a:t>
+              <a:t>Google's Neural Machine Translation System: Bridging the Gap between Human and Machine Translation</a:t>
             </a:r>
           </a:p>
           <a:p>
@@ -19464,7 +19457,7 @@
                 <a:ea typeface="Noto Sans CJK JP"/>
                 <a:cs typeface="Noto Sans"/>
               </a:rPr>
-              <a:t>wmt/wmt14 / 改訂b199e406 / 2026-10-18参照</a:t>
+              <a:t>Yonghui Wu et al. / arXiv 2016</a:t>
             </a:r>
           </a:p>
           <a:p>
@@ -19495,7 +19488,7 @@
                 <a:ea typeface="Noto Sans CJK JP"/>
                 <a:cs typeface="Noto Sans"/>
               </a:rPr>
-              <a:t>掲載した13件の対訳と、言語組ごとの全件集計に用いた公開資源。</a:t>
+              <a:t>語の分割法などを比べ、WMT14の翻訳結果を報告した。</a:t>
             </a:r>
           </a:p>
           <a:p>
@@ -19527,7 +19520,7 @@
                 <a:cs typeface="Noto Sans"/>
                 <a:hlinkClick r:id="rId2"/>
               </a:rPr>
-              <a:t>https://huggingface.co/datasets/wmt/wmt14</a:t>
+              <a:t>https://arxiv.org/abs/1609.08144</a:t>
             </a:r>
           </a:p>
         </p:txBody>
@@ -19648,7 +19641,7 @@
       </p:sp>
       <p:sp>
         <p:nvSpPr>
-          <p:cNvPr id="4" name="文献 1: Google's Neural Machine Translation System: Bridging the Gap between Human and Machine Translation"/>
+          <p:cNvPr id="4" name="文献 1: Attention Is All You Need"/>
           <p:cNvSpPr txBox="1"/>
           <p:nvPr/>
         </p:nvSpPr>
@@ -19695,7 +19688,7 @@
                 <a:ea typeface="Noto Sans CJK JP"/>
                 <a:cs typeface="Noto Sans"/>
               </a:rPr>
-              <a:t>Google's Neural Machine Translation System: Bridging the Gap between Human and Machine Translation</a:t>
+              <a:t>Attention Is All You Need</a:t>
             </a:r>
           </a:p>
           <a:p>
@@ -19726,7 +19719,7 @@
                 <a:ea typeface="Noto Sans CJK JP"/>
                 <a:cs typeface="Noto Sans"/>
               </a:rPr>
-              <a:t>Yonghui Wu et al. / arXiv 2016</a:t>
+              <a:t>Ashish Vaswani et al. / NeurIPS 2017</a:t>
             </a:r>
           </a:p>
           <a:p>
@@ -19757,7 +19750,7 @@
                 <a:ea typeface="Noto Sans CJK JP"/>
                 <a:cs typeface="Noto Sans"/>
               </a:rPr>
-              <a:t>語の分割法などを比べ、WMT14の翻訳結果を報告した。</a:t>
+              <a:t>注意機構を中心とするTransformerと、WMT14での評価を報告。</a:t>
             </a:r>
           </a:p>
           <a:p>
@@ -19789,7 +19782,7 @@
                 <a:cs typeface="Noto Sans"/>
                 <a:hlinkClick r:id="rId2"/>
               </a:rPr>
-              <a:t>https://arxiv.org/abs/1609.08144</a:t>
+              <a:t>https://arxiv.org/abs/1706.03762</a:t>
             </a:r>
           </a:p>
         </p:txBody>
@@ -19803,268 +19796,6 @@
 </file>
 
 <file path=ppt/slides/slide46.xml><?xml version="1.0" encoding="utf-8"?>
-<p:sld xmlns:a="http://schemas.openxmlformats.org/drawingml/2006/main" xmlns:p="http://schemas.openxmlformats.org/presentationml/2006/main" xmlns:r="http://schemas.openxmlformats.org/officeDocument/2006/relationships">
-  <p:cSld>
-    <p:spTree>
-      <p:nvGrpSpPr>
-        <p:cNvPr id="1" name=""/>
-        <p:cNvGrpSpPr/>
-        <p:nvPr/>
-      </p:nvGrpSpPr>
-      <p:grpSpPr/>
-      <p:sp>
-        <p:nvSpPr>
-          <p:cNvPr id="2" name="Title 1"/>
-          <p:cNvSpPr>
-            <a:spLocks noGrp="1"/>
-          </p:cNvSpPr>
-          <p:nvPr>
-            <p:ph type="title"/>
-          </p:nvPr>
-        </p:nvSpPr>
-        <p:spPr>
-          <a:xfrm>
-            <a:off x="468172" y="650138"/>
-            <a:ext cx="8206740" cy="616305"/>
-          </a:xfrm>
-        </p:spPr>
-        <p:txBody>
-          <a:bodyPr wrap="square" lIns="0" rIns="0" tIns="0" bIns="0">
-            <a:noAutofit/>
-          </a:bodyPr>
-          <a:lstStyle/>
-          <a:p>
-            <a:pPr algn="l">
-              <a:lnSpc>
-                <a:spcPct val="110000"/>
-              </a:lnSpc>
-              <a:buNone/>
-              <a:defRPr sz="2800" b="0">
-                <a:solidFill>
-                  <a:srgbClr val="303437"/>
-                </a:solidFill>
-                <a:latin typeface="Noto Sans"/>
-              </a:defRPr>
-            </a:pPr>
-            <a:r>
-              <a:rPr sz="2800" b="1" lang="ja-JP" altLang="en-US">
-                <a:solidFill>
-                  <a:srgbClr val="303437"/>
-                </a:solidFill>
-                <a:latin typeface="Noto Sans"/>
-                <a:ea typeface="Noto Sans CJK JP"/>
-                <a:cs typeface="Noto Sans"/>
-              </a:rPr>
-              <a:t>参考文献</a:t>
-            </a:r>
-          </a:p>
-        </p:txBody>
-      </p:sp>
-      <p:sp>
-        <p:nvSpPr>
-          <p:cNvPr id="3" name="Title 2"/>
-          <p:cNvSpPr>
-            <a:spLocks noGrp="1"/>
-          </p:cNvSpPr>
-          <p:nvPr>
-            <p:ph type="title" idx="2"/>
-          </p:nvPr>
-        </p:nvSpPr>
-        <p:spPr>
-          <a:xfrm>
-            <a:off x="75895" y="0"/>
-            <a:ext cx="8115300" cy="480060"/>
-          </a:xfrm>
-        </p:spPr>
-        <p:txBody>
-          <a:bodyPr wrap="square" lIns="0" rIns="0" tIns="0" bIns="0" anchor="ctr">
-            <a:noAutofit/>
-          </a:bodyPr>
-          <a:lstStyle/>
-          <a:p>
-            <a:pPr algn="l">
-              <a:lnSpc>
-                <a:spcPct val="110000"/>
-              </a:lnSpc>
-              <a:buNone/>
-              <a:defRPr sz="1400" b="0">
-                <a:solidFill>
-                  <a:srgbClr val="303437"/>
-                </a:solidFill>
-                <a:latin typeface="Noto Sans"/>
-              </a:defRPr>
-            </a:pPr>
-            <a:r>
-              <a:rPr sz="1400" b="1" lang="ja-JP" altLang="en-US">
-                <a:solidFill>
-                  <a:srgbClr val="FFFEF8"/>
-                </a:solidFill>
-                <a:latin typeface="Noto Sans"/>
-                <a:ea typeface="Noto Sans CJK JP"/>
-                <a:cs typeface="Noto Sans"/>
-              </a:rPr>
-              <a:t>Appendix: 3. 研究と参考文献</a:t>
-            </a:r>
-          </a:p>
-        </p:txBody>
-      </p:sp>
-      <p:sp>
-        <p:nvSpPr>
-          <p:cNvPr id="4" name="文献 1: Attention Is All You Need"/>
-          <p:cNvSpPr txBox="1"/>
-          <p:nvPr/>
-        </p:nvSpPr>
-        <p:spPr>
-          <a:xfrm>
-            <a:off x="548640" y="1463040"/>
-            <a:ext cx="8046720" cy="3200400"/>
-          </a:xfrm>
-          <a:prstGeom prst="rect">
-            <a:avLst/>
-          </a:prstGeom>
-          <a:noFill/>
-        </p:spPr>
-        <p:txBody>
-          <a:bodyPr wrap="square" lIns="0" rIns="0" tIns="0" bIns="0">
-            <a:noAutofit/>
-          </a:bodyPr>
-          <a:lstStyle/>
-          <a:p>
-            <a:pPr algn="l">
-              <a:lnSpc>
-                <a:spcPct val="114000"/>
-              </a:lnSpc>
-              <a:spcBef>
-                <a:spcPts val="0"/>
-              </a:spcBef>
-              <a:spcAft>
-                <a:spcPts val="400"/>
-              </a:spcAft>
-              <a:buNone/>
-              <a:defRPr sz="2000" b="0">
-                <a:solidFill>
-                  <a:srgbClr val="303437"/>
-                </a:solidFill>
-                <a:latin typeface="Noto Sans"/>
-              </a:defRPr>
-            </a:pPr>
-            <a:r>
-              <a:rPr sz="2000" b="1" lang="ja-JP" altLang="en-US">
-                <a:solidFill>
-                  <a:srgbClr val="303437"/>
-                </a:solidFill>
-                <a:latin typeface="Noto Sans"/>
-                <a:ea typeface="Noto Sans CJK JP"/>
-                <a:cs typeface="Noto Sans"/>
-              </a:rPr>
-              <a:t>Attention Is All You Need</a:t>
-            </a:r>
-          </a:p>
-          <a:p>
-            <a:pPr algn="l">
-              <a:lnSpc>
-                <a:spcPct val="114000"/>
-              </a:lnSpc>
-              <a:spcBef>
-                <a:spcPts val="0"/>
-              </a:spcBef>
-              <a:spcAft>
-                <a:spcPts val="500"/>
-              </a:spcAft>
-              <a:buNone/>
-              <a:defRPr sz="1350" b="0">
-                <a:solidFill>
-                  <a:srgbClr val="303437"/>
-                </a:solidFill>
-                <a:latin typeface="Noto Sans"/>
-              </a:defRPr>
-            </a:pPr>
-            <a:r>
-              <a:rPr sz="1350" b="0" lang="ja-JP" altLang="en-US">
-                <a:solidFill>
-                  <a:srgbClr val="626669"/>
-                </a:solidFill>
-                <a:latin typeface="Noto Sans"/>
-                <a:ea typeface="Noto Sans CJK JP"/>
-                <a:cs typeface="Noto Sans"/>
-              </a:rPr>
-              <a:t>Ashish Vaswani et al. / NeurIPS 2017</a:t>
-            </a:r>
-          </a:p>
-          <a:p>
-            <a:pPr algn="l">
-              <a:lnSpc>
-                <a:spcPct val="114000"/>
-              </a:lnSpc>
-              <a:spcBef>
-                <a:spcPts val="0"/>
-              </a:spcBef>
-              <a:spcAft>
-                <a:spcPts val="400"/>
-              </a:spcAft>
-              <a:buNone/>
-              <a:defRPr sz="1850" b="0">
-                <a:solidFill>
-                  <a:srgbClr val="303437"/>
-                </a:solidFill>
-                <a:latin typeface="Noto Sans"/>
-              </a:defRPr>
-            </a:pPr>
-            <a:r>
-              <a:rPr sz="1850" b="0" lang="ja-JP" altLang="en-US">
-                <a:solidFill>
-                  <a:srgbClr val="303437"/>
-                </a:solidFill>
-                <a:latin typeface="Noto Sans"/>
-                <a:ea typeface="Noto Sans CJK JP"/>
-                <a:cs typeface="Noto Sans"/>
-              </a:rPr>
-              <a:t>注意機構を中心とするTransformerと、WMT14での評価を報告。</a:t>
-            </a:r>
-          </a:p>
-          <a:p>
-            <a:pPr algn="l">
-              <a:lnSpc>
-                <a:spcPct val="114000"/>
-              </a:lnSpc>
-              <a:spcBef>
-                <a:spcPts val="0"/>
-              </a:spcBef>
-              <a:spcAft>
-                <a:spcPts val="0"/>
-              </a:spcAft>
-              <a:buNone/>
-              <a:defRPr sz="1150" b="0">
-                <a:solidFill>
-                  <a:srgbClr val="303437"/>
-                </a:solidFill>
-                <a:latin typeface="Noto Sans"/>
-              </a:defRPr>
-            </a:pPr>
-            <a:r>
-              <a:rPr sz="1150" b="0" lang="ja-JP" altLang="en-US">
-                <a:solidFill>
-                  <a:srgbClr val="626669"/>
-                </a:solidFill>
-                <a:latin typeface="Noto Sans"/>
-                <a:ea typeface="Noto Sans CJK JP"/>
-                <a:cs typeface="Noto Sans"/>
-                <a:hlinkClick r:id="rId2"/>
-              </a:rPr>
-              <a:t>https://arxiv.org/abs/1706.03762</a:t>
-            </a:r>
-          </a:p>
-        </p:txBody>
-      </p:sp>
-    </p:spTree>
-  </p:cSld>
-  <p:clrMapOvr>
-    <a:masterClrMapping/>
-  </p:clrMapOvr>
-</p:sld>
-</file>
-
-<file path=ppt/slides/slide47.xml><?xml version="1.0" encoding="utf-8"?>
 <p:sld xmlns:a="http://schemas.openxmlformats.org/drawingml/2006/main" xmlns:p="http://schemas.openxmlformats.org/presentationml/2006/main" xmlns:r="http://schemas.openxmlformats.org/officeDocument/2006/relationships">
   <p:cSld>
     <p:spTree>

</xml_diff>